<commit_message>
Fall 2026 New version with fewer lectures. I combined lectures 27 and 28 by spliting 27 an tacking part onto 26 and part onto 28 so there was one fewer lecture.
</commit_message>
<xml_diff>
--- a/Lecture_Slides/PH 123 Lecture 04.pptx
+++ b/Lecture_Slides/PH 123 Lecture 04.pptx
@@ -5,7 +5,7 @@
     <p:sldMasterId id="2147483648" r:id="rId1"/>
   </p:sldMasterIdLst>
   <p:notesMasterIdLst>
-    <p:notesMasterId r:id="rId49"/>
+    <p:notesMasterId r:id="rId50"/>
   </p:notesMasterIdLst>
   <p:sldIdLst>
     <p:sldId id="395" r:id="rId2"/>
@@ -17,44 +17,45 @@
     <p:sldId id="388" r:id="rId8"/>
     <p:sldId id="389" r:id="rId9"/>
     <p:sldId id="390" r:id="rId10"/>
-    <p:sldId id="397" r:id="rId11"/>
-    <p:sldId id="391" r:id="rId12"/>
-    <p:sldId id="396" r:id="rId13"/>
-    <p:sldId id="274" r:id="rId14"/>
-    <p:sldId id="275" r:id="rId15"/>
-    <p:sldId id="276" r:id="rId16"/>
-    <p:sldId id="277" r:id="rId17"/>
-    <p:sldId id="287" r:id="rId18"/>
-    <p:sldId id="288" r:id="rId19"/>
-    <p:sldId id="278" r:id="rId20"/>
-    <p:sldId id="299" r:id="rId21"/>
-    <p:sldId id="310" r:id="rId22"/>
-    <p:sldId id="311" r:id="rId23"/>
-    <p:sldId id="279" r:id="rId24"/>
-    <p:sldId id="280" r:id="rId25"/>
-    <p:sldId id="281" r:id="rId26"/>
-    <p:sldId id="285" r:id="rId27"/>
-    <p:sldId id="273" r:id="rId28"/>
-    <p:sldId id="270" r:id="rId29"/>
-    <p:sldId id="271" r:id="rId30"/>
-    <p:sldId id="286" r:id="rId31"/>
-    <p:sldId id="312" r:id="rId32"/>
-    <p:sldId id="258" r:id="rId33"/>
-    <p:sldId id="257" r:id="rId34"/>
-    <p:sldId id="398" r:id="rId35"/>
-    <p:sldId id="289" r:id="rId36"/>
-    <p:sldId id="290" r:id="rId37"/>
-    <p:sldId id="291" r:id="rId38"/>
-    <p:sldId id="292" r:id="rId39"/>
-    <p:sldId id="293" r:id="rId40"/>
-    <p:sldId id="294" r:id="rId41"/>
-    <p:sldId id="295" r:id="rId42"/>
-    <p:sldId id="296" r:id="rId43"/>
-    <p:sldId id="297" r:id="rId44"/>
-    <p:sldId id="298" r:id="rId45"/>
-    <p:sldId id="282" r:id="rId46"/>
-    <p:sldId id="283" r:id="rId47"/>
-    <p:sldId id="284" r:id="rId48"/>
+    <p:sldId id="399" r:id="rId11"/>
+    <p:sldId id="397" r:id="rId12"/>
+    <p:sldId id="391" r:id="rId13"/>
+    <p:sldId id="396" r:id="rId14"/>
+    <p:sldId id="274" r:id="rId15"/>
+    <p:sldId id="275" r:id="rId16"/>
+    <p:sldId id="276" r:id="rId17"/>
+    <p:sldId id="277" r:id="rId18"/>
+    <p:sldId id="287" r:id="rId19"/>
+    <p:sldId id="288" r:id="rId20"/>
+    <p:sldId id="278" r:id="rId21"/>
+    <p:sldId id="299" r:id="rId22"/>
+    <p:sldId id="310" r:id="rId23"/>
+    <p:sldId id="311" r:id="rId24"/>
+    <p:sldId id="279" r:id="rId25"/>
+    <p:sldId id="280" r:id="rId26"/>
+    <p:sldId id="281" r:id="rId27"/>
+    <p:sldId id="285" r:id="rId28"/>
+    <p:sldId id="273" r:id="rId29"/>
+    <p:sldId id="270" r:id="rId30"/>
+    <p:sldId id="271" r:id="rId31"/>
+    <p:sldId id="286" r:id="rId32"/>
+    <p:sldId id="312" r:id="rId33"/>
+    <p:sldId id="258" r:id="rId34"/>
+    <p:sldId id="257" r:id="rId35"/>
+    <p:sldId id="398" r:id="rId36"/>
+    <p:sldId id="289" r:id="rId37"/>
+    <p:sldId id="290" r:id="rId38"/>
+    <p:sldId id="291" r:id="rId39"/>
+    <p:sldId id="292" r:id="rId40"/>
+    <p:sldId id="293" r:id="rId41"/>
+    <p:sldId id="294" r:id="rId42"/>
+    <p:sldId id="295" r:id="rId43"/>
+    <p:sldId id="296" r:id="rId44"/>
+    <p:sldId id="297" r:id="rId45"/>
+    <p:sldId id="298" r:id="rId46"/>
+    <p:sldId id="282" r:id="rId47"/>
+    <p:sldId id="283" r:id="rId48"/>
+    <p:sldId id="284" r:id="rId49"/>
   </p:sldIdLst>
   <p:sldSz cx="9144000" cy="6858000" type="screen4x3"/>
   <p:notesSz cx="6858000" cy="9144000"/>
@@ -172,234 +173,52 @@
 </p:presentation>
 </file>
 
-<file path=ppt/revisionInfo.xml><?xml version="1.0" encoding="utf-8"?>
-<p1510:revInfo xmlns:a="http://schemas.openxmlformats.org/drawingml/2006/main" xmlns:r="http://schemas.openxmlformats.org/officeDocument/2006/relationships" xmlns:p1510="http://schemas.microsoft.com/office/powerpoint/2015/10/main">
-  <p1510:revLst>
-    <p1510:client id="{2B3D251A-BFC7-4975-A9F2-C2C806C625C9}" v="46" dt="2026-04-22T21:08:29.484"/>
-  </p1510:revLst>
-</p1510:revInfo>
-</file>
-
 <file path=ppt/changesInfos/changesInfo1.xml><?xml version="1.0" encoding="utf-8"?>
 <pc:chgInfo xmlns:a="http://schemas.openxmlformats.org/drawingml/2006/main" xmlns:r="http://schemas.openxmlformats.org/officeDocument/2006/relationships" xmlns:ac="http://schemas.microsoft.com/office/drawing/2013/main/command" xmlns:pc="http://schemas.microsoft.com/office/powerpoint/2013/main/command">
   <pc:docChgLst>
-    <pc:chgData name="Lines, Todd" userId="afaf7c3a-e8aa-4568-882a-02ad8f9e19b0" providerId="ADAL" clId="{5FF5AC1B-ABA9-43D7-A1E3-2D92732CD6E2}"/>
-    <pc:docChg chg="undo custSel modSld">
-      <pc:chgData name="Lines, Todd" userId="afaf7c3a-e8aa-4568-882a-02ad8f9e19b0" providerId="ADAL" clId="{5FF5AC1B-ABA9-43D7-A1E3-2D92732CD6E2}" dt="2026-04-22T21:08:29.484" v="174" actId="6549"/>
+    <pc:chgData name="Todd Lines" userId="afaf7c3a-e8aa-4568-882a-02ad8f9e19b0" providerId="ADAL" clId="{5FF5AC1B-ABA9-43D7-A1E3-2D92732CD6E2}"/>
+    <pc:docChg chg="custSel addSld modSld">
+      <pc:chgData name="Todd Lines" userId="afaf7c3a-e8aa-4568-882a-02ad8f9e19b0" providerId="ADAL" clId="{5FF5AC1B-ABA9-43D7-A1E3-2D92732CD6E2}" dt="2026-08-17T20:35:19.437" v="9" actId="21"/>
       <pc:docMkLst>
         <pc:docMk/>
       </pc:docMkLst>
       <pc:sldChg chg="addSp delSp modSp mod">
-        <pc:chgData name="Lines, Todd" userId="afaf7c3a-e8aa-4568-882a-02ad8f9e19b0" providerId="ADAL" clId="{5FF5AC1B-ABA9-43D7-A1E3-2D92732CD6E2}" dt="2026-04-22T21:05:53.764" v="106" actId="20577"/>
+        <pc:chgData name="Todd Lines" userId="afaf7c3a-e8aa-4568-882a-02ad8f9e19b0" providerId="ADAL" clId="{5FF5AC1B-ABA9-43D7-A1E3-2D92732CD6E2}" dt="2026-08-17T20:35:19.437" v="9" actId="21"/>
         <pc:sldMkLst>
           <pc:docMk/>
-          <pc:sldMk cId="0" sldId="386"/>
+          <pc:sldMk cId="0" sldId="390"/>
         </pc:sldMkLst>
-        <pc:spChg chg="add mod">
-          <ac:chgData name="Lines, Todd" userId="afaf7c3a-e8aa-4568-882a-02ad8f9e19b0" providerId="ADAL" clId="{5FF5AC1B-ABA9-43D7-A1E3-2D92732CD6E2}" dt="2026-04-22T21:05:48.983" v="102" actId="20577"/>
+        <pc:spChg chg="mod">
+          <ac:chgData name="Todd Lines" userId="afaf7c3a-e8aa-4568-882a-02ad8f9e19b0" providerId="ADAL" clId="{5FF5AC1B-ABA9-43D7-A1E3-2D92732CD6E2}" dt="2026-08-17T20:34:57.805" v="5" actId="14100"/>
           <ac:spMkLst>
             <pc:docMk/>
-            <pc:sldMk cId="0" sldId="386"/>
-            <ac:spMk id="20488" creationId="{00000000-0000-0000-0000-000000000000}"/>
+            <pc:sldMk cId="0" sldId="390"/>
+            <ac:spMk id="1030" creationId="{00000000-0000-0000-0000-000000000000}"/>
           </ac:spMkLst>
         </pc:spChg>
-        <pc:spChg chg="add mod">
-          <ac:chgData name="Lines, Todd" userId="afaf7c3a-e8aa-4568-882a-02ad8f9e19b0" providerId="ADAL" clId="{5FF5AC1B-ABA9-43D7-A1E3-2D92732CD6E2}" dt="2026-04-22T21:05:02.406" v="76" actId="20577"/>
-          <ac:spMkLst>
+        <pc:picChg chg="add mod">
+          <ac:chgData name="Todd Lines" userId="afaf7c3a-e8aa-4568-882a-02ad8f9e19b0" providerId="ADAL" clId="{5FF5AC1B-ABA9-43D7-A1E3-2D92732CD6E2}" dt="2026-08-17T20:35:00.420" v="6" actId="1076"/>
+          <ac:picMkLst>
             <pc:docMk/>
-            <pc:sldMk cId="0" sldId="386"/>
-            <ac:spMk id="20490" creationId="{00000000-0000-0000-0000-000000000000}"/>
-          </ac:spMkLst>
-        </pc:spChg>
-        <pc:spChg chg="add mod">
-          <ac:chgData name="Lines, Todd" userId="afaf7c3a-e8aa-4568-882a-02ad8f9e19b0" providerId="ADAL" clId="{5FF5AC1B-ABA9-43D7-A1E3-2D92732CD6E2}" dt="2026-04-22T21:05:53.764" v="106" actId="20577"/>
-          <ac:spMkLst>
+            <pc:sldMk cId="0" sldId="390"/>
+            <ac:picMk id="2" creationId="{97DA0287-7C11-6853-614F-8CB4B73A9652}"/>
+          </ac:picMkLst>
+        </pc:picChg>
+        <pc:picChg chg="add del mod">
+          <ac:chgData name="Todd Lines" userId="afaf7c3a-e8aa-4568-882a-02ad8f9e19b0" providerId="ADAL" clId="{5FF5AC1B-ABA9-43D7-A1E3-2D92732CD6E2}" dt="2026-08-17T20:35:19.437" v="9" actId="21"/>
+          <ac:picMkLst>
             <pc:docMk/>
-            <pc:sldMk cId="0" sldId="386"/>
-            <ac:spMk id="20491" creationId="{00000000-0000-0000-0000-000000000000}"/>
-          </ac:spMkLst>
-        </pc:spChg>
-        <pc:spChg chg="add mod">
-          <ac:chgData name="Lines, Todd" userId="afaf7c3a-e8aa-4568-882a-02ad8f9e19b0" providerId="ADAL" clId="{5FF5AC1B-ABA9-43D7-A1E3-2D92732CD6E2}" dt="2026-04-22T21:05:36.244" v="93" actId="14100"/>
-          <ac:spMkLst>
-            <pc:docMk/>
-            <pc:sldMk cId="0" sldId="386"/>
-            <ac:spMk id="20492" creationId="{00000000-0000-0000-0000-000000000000}"/>
-          </ac:spMkLst>
-        </pc:spChg>
-        <pc:graphicFrameChg chg="del mod replId">
-          <ac:chgData name="Lines, Todd" userId="afaf7c3a-e8aa-4568-882a-02ad8f9e19b0" providerId="ADAL" clId="{5FF5AC1B-ABA9-43D7-A1E3-2D92732CD6E2}" dt="2026-04-22T21:04:44.896" v="65"/>
-          <ac:graphicFrameMkLst>
-            <pc:docMk/>
-            <pc:sldMk cId="0" sldId="386"/>
-            <ac:graphicFrameMk id="2" creationId="{00000000-0000-0000-0000-000000000000}"/>
-          </ac:graphicFrameMkLst>
-        </pc:graphicFrameChg>
-        <pc:graphicFrameChg chg="del mod replId">
-          <ac:chgData name="Lines, Todd" userId="afaf7c3a-e8aa-4568-882a-02ad8f9e19b0" providerId="ADAL" clId="{5FF5AC1B-ABA9-43D7-A1E3-2D92732CD6E2}" dt="2026-04-22T21:04:58.997" v="73"/>
-          <ac:graphicFrameMkLst>
-            <pc:docMk/>
-            <pc:sldMk cId="0" sldId="386"/>
-            <ac:graphicFrameMk id="4" creationId="{00000000-0000-0000-0000-000000000000}"/>
-          </ac:graphicFrameMkLst>
-        </pc:graphicFrameChg>
-        <pc:graphicFrameChg chg="del mod replId">
-          <ac:chgData name="Lines, Todd" userId="afaf7c3a-e8aa-4568-882a-02ad8f9e19b0" providerId="ADAL" clId="{5FF5AC1B-ABA9-43D7-A1E3-2D92732CD6E2}" dt="2026-04-22T21:05:10.387" v="78"/>
-          <ac:graphicFrameMkLst>
-            <pc:docMk/>
-            <pc:sldMk cId="0" sldId="386"/>
-            <ac:graphicFrameMk id="6" creationId="{00000000-0000-0000-0000-000000000000}"/>
-          </ac:graphicFrameMkLst>
-        </pc:graphicFrameChg>
-        <pc:graphicFrameChg chg="del mod replId">
-          <ac:chgData name="Lines, Todd" userId="afaf7c3a-e8aa-4568-882a-02ad8f9e19b0" providerId="ADAL" clId="{5FF5AC1B-ABA9-43D7-A1E3-2D92732CD6E2}" dt="2026-04-22T21:05:13.156" v="81"/>
-          <ac:graphicFrameMkLst>
-            <pc:docMk/>
-            <pc:sldMk cId="0" sldId="386"/>
-            <ac:graphicFrameMk id="8" creationId="{00000000-0000-0000-0000-000000000000}"/>
-          </ac:graphicFrameMkLst>
-        </pc:graphicFrameChg>
+            <pc:sldMk cId="0" sldId="390"/>
+            <ac:picMk id="4" creationId="{BCE4F324-8B92-F631-0B80-BC90EE5CA5EE}"/>
+          </ac:picMkLst>
+        </pc:picChg>
       </pc:sldChg>
-      <pc:sldChg chg="addSp delSp modSp mod">
-        <pc:chgData name="Lines, Todd" userId="afaf7c3a-e8aa-4568-882a-02ad8f9e19b0" providerId="ADAL" clId="{5FF5AC1B-ABA9-43D7-A1E3-2D92732CD6E2}" dt="2026-04-22T21:06:09.421" v="116" actId="20577"/>
+      <pc:sldChg chg="new">
+        <pc:chgData name="Todd Lines" userId="afaf7c3a-e8aa-4568-882a-02ad8f9e19b0" providerId="ADAL" clId="{5FF5AC1B-ABA9-43D7-A1E3-2D92732CD6E2}" dt="2026-08-17T20:34:43.998" v="0" actId="680"/>
         <pc:sldMkLst>
           <pc:docMk/>
-          <pc:sldMk cId="0" sldId="387"/>
+          <pc:sldMk cId="1986014694" sldId="399"/>
         </pc:sldMkLst>
-        <pc:spChg chg="add mod">
-          <ac:chgData name="Lines, Todd" userId="afaf7c3a-e8aa-4568-882a-02ad8f9e19b0" providerId="ADAL" clId="{5FF5AC1B-ABA9-43D7-A1E3-2D92732CD6E2}" dt="2026-04-22T21:06:09.421" v="116" actId="20577"/>
-          <ac:spMkLst>
-            <pc:docMk/>
-            <pc:sldMk cId="0" sldId="387"/>
-            <ac:spMk id="21510" creationId="{00000000-0000-0000-0000-000000000000}"/>
-          </ac:spMkLst>
-        </pc:spChg>
-        <pc:graphicFrameChg chg="del mod replId">
-          <ac:chgData name="Lines, Todd" userId="afaf7c3a-e8aa-4568-882a-02ad8f9e19b0" providerId="ADAL" clId="{5FF5AC1B-ABA9-43D7-A1E3-2D92732CD6E2}" dt="2026-04-22T21:05:41.586" v="95"/>
-          <ac:graphicFrameMkLst>
-            <pc:docMk/>
-            <pc:sldMk cId="0" sldId="387"/>
-            <ac:graphicFrameMk id="2" creationId="{00000000-0000-0000-0000-000000000000}"/>
-          </ac:graphicFrameMkLst>
-        </pc:graphicFrameChg>
-      </pc:sldChg>
-      <pc:sldChg chg="addSp delSp modSp mod">
-        <pc:chgData name="Lines, Todd" userId="afaf7c3a-e8aa-4568-882a-02ad8f9e19b0" providerId="ADAL" clId="{5FF5AC1B-ABA9-43D7-A1E3-2D92732CD6E2}" dt="2026-04-22T21:06:21.337" v="124" actId="20577"/>
-        <pc:sldMkLst>
-          <pc:docMk/>
-          <pc:sldMk cId="0" sldId="388"/>
-        </pc:sldMkLst>
-        <pc:spChg chg="add mod">
-          <ac:chgData name="Lines, Todd" userId="afaf7c3a-e8aa-4568-882a-02ad8f9e19b0" providerId="ADAL" clId="{5FF5AC1B-ABA9-43D7-A1E3-2D92732CD6E2}" dt="2026-04-22T21:06:21.337" v="124" actId="20577"/>
-          <ac:spMkLst>
-            <pc:docMk/>
-            <pc:sldMk cId="0" sldId="388"/>
-            <ac:spMk id="22536" creationId="{00000000-0000-0000-0000-000000000000}"/>
-          </ac:spMkLst>
-        </pc:spChg>
-        <pc:graphicFrameChg chg="del mod replId">
-          <ac:chgData name="Lines, Todd" userId="afaf7c3a-e8aa-4568-882a-02ad8f9e19b0" providerId="ADAL" clId="{5FF5AC1B-ABA9-43D7-A1E3-2D92732CD6E2}" dt="2026-04-22T21:06:17.536" v="118"/>
-          <ac:graphicFrameMkLst>
-            <pc:docMk/>
-            <pc:sldMk cId="0" sldId="388"/>
-            <ac:graphicFrameMk id="2" creationId="{00000000-0000-0000-0000-000000000000}"/>
-          </ac:graphicFrameMkLst>
-        </pc:graphicFrameChg>
-      </pc:sldChg>
-      <pc:sldChg chg="addSp delSp modSp mod">
-        <pc:chgData name="Lines, Todd" userId="afaf7c3a-e8aa-4568-882a-02ad8f9e19b0" providerId="ADAL" clId="{5FF5AC1B-ABA9-43D7-A1E3-2D92732CD6E2}" dt="2026-04-22T21:08:29.484" v="174" actId="6549"/>
-        <pc:sldMkLst>
-          <pc:docMk/>
-          <pc:sldMk cId="0" sldId="391"/>
-        </pc:sldMkLst>
-        <pc:spChg chg="add mod">
-          <ac:chgData name="Lines, Todd" userId="afaf7c3a-e8aa-4568-882a-02ad8f9e19b0" providerId="ADAL" clId="{5FF5AC1B-ABA9-43D7-A1E3-2D92732CD6E2}" dt="2026-04-22T21:07:46.291" v="159" actId="20577"/>
-          <ac:spMkLst>
-            <pc:docMk/>
-            <pc:sldMk cId="0" sldId="391"/>
-            <ac:spMk id="24597" creationId="{00000000-0000-0000-0000-000000000000}"/>
-          </ac:spMkLst>
-        </pc:spChg>
-        <pc:spChg chg="add mod">
-          <ac:chgData name="Lines, Todd" userId="afaf7c3a-e8aa-4568-882a-02ad8f9e19b0" providerId="ADAL" clId="{5FF5AC1B-ABA9-43D7-A1E3-2D92732CD6E2}" dt="2026-04-22T21:07:11.743" v="145" actId="20577"/>
-          <ac:spMkLst>
-            <pc:docMk/>
-            <pc:sldMk cId="0" sldId="391"/>
-            <ac:spMk id="24598" creationId="{00000000-0000-0000-0000-000000000000}"/>
-          </ac:spMkLst>
-        </pc:spChg>
-        <pc:spChg chg="add mod">
-          <ac:chgData name="Lines, Todd" userId="afaf7c3a-e8aa-4568-882a-02ad8f9e19b0" providerId="ADAL" clId="{5FF5AC1B-ABA9-43D7-A1E3-2D92732CD6E2}" dt="2026-04-22T21:07:29.732" v="155" actId="20577"/>
-          <ac:spMkLst>
-            <pc:docMk/>
-            <pc:sldMk cId="0" sldId="391"/>
-            <ac:spMk id="24599" creationId="{00000000-0000-0000-0000-000000000000}"/>
-          </ac:spMkLst>
-        </pc:spChg>
-        <pc:spChg chg="add mod">
-          <ac:chgData name="Lines, Todd" userId="afaf7c3a-e8aa-4568-882a-02ad8f9e19b0" providerId="ADAL" clId="{5FF5AC1B-ABA9-43D7-A1E3-2D92732CD6E2}" dt="2026-04-22T21:08:29.484" v="174" actId="6549"/>
-          <ac:spMkLst>
-            <pc:docMk/>
-            <pc:sldMk cId="0" sldId="391"/>
-            <ac:spMk id="24600" creationId="{00000000-0000-0000-0000-000000000000}"/>
-          </ac:spMkLst>
-        </pc:spChg>
-        <pc:spChg chg="add mod">
-          <ac:chgData name="Lines, Todd" userId="afaf7c3a-e8aa-4568-882a-02ad8f9e19b0" providerId="ADAL" clId="{5FF5AC1B-ABA9-43D7-A1E3-2D92732CD6E2}" dt="2026-04-22T21:08:19.995" v="170" actId="20577"/>
-          <ac:spMkLst>
-            <pc:docMk/>
-            <pc:sldMk cId="0" sldId="391"/>
-            <ac:spMk id="24601" creationId="{00000000-0000-0000-0000-000000000000}"/>
-          </ac:spMkLst>
-        </pc:spChg>
-        <pc:graphicFrameChg chg="del mod replId">
-          <ac:chgData name="Lines, Todd" userId="afaf7c3a-e8aa-4568-882a-02ad8f9e19b0" providerId="ADAL" clId="{5FF5AC1B-ABA9-43D7-A1E3-2D92732CD6E2}" dt="2026-04-22T21:06:47.138" v="126"/>
-          <ac:graphicFrameMkLst>
-            <pc:docMk/>
-            <pc:sldMk cId="0" sldId="391"/>
-            <ac:graphicFrameMk id="2" creationId="{00000000-0000-0000-0000-000000000000}"/>
-          </ac:graphicFrameMkLst>
-        </pc:graphicFrameChg>
-        <pc:graphicFrameChg chg="del mod replId">
-          <ac:chgData name="Lines, Todd" userId="afaf7c3a-e8aa-4568-882a-02ad8f9e19b0" providerId="ADAL" clId="{5FF5AC1B-ABA9-43D7-A1E3-2D92732CD6E2}" dt="2026-04-22T21:06:50.360" v="129"/>
-          <ac:graphicFrameMkLst>
-            <pc:docMk/>
-            <pc:sldMk cId="0" sldId="391"/>
-            <ac:graphicFrameMk id="4" creationId="{00000000-0000-0000-0000-000000000000}"/>
-          </ac:graphicFrameMkLst>
-        </pc:graphicFrameChg>
-        <pc:graphicFrameChg chg="del mod replId">
-          <ac:chgData name="Lines, Todd" userId="afaf7c3a-e8aa-4568-882a-02ad8f9e19b0" providerId="ADAL" clId="{5FF5AC1B-ABA9-43D7-A1E3-2D92732CD6E2}" dt="2026-04-22T21:06:52.521" v="132"/>
-          <ac:graphicFrameMkLst>
-            <pc:docMk/>
-            <pc:sldMk cId="0" sldId="391"/>
-            <ac:graphicFrameMk id="6" creationId="{00000000-0000-0000-0000-000000000000}"/>
-          </ac:graphicFrameMkLst>
-        </pc:graphicFrameChg>
-        <pc:graphicFrameChg chg="del mod replId">
-          <ac:chgData name="Lines, Todd" userId="afaf7c3a-e8aa-4568-882a-02ad8f9e19b0" providerId="ADAL" clId="{5FF5AC1B-ABA9-43D7-A1E3-2D92732CD6E2}" dt="2026-04-22T21:06:55.098" v="135"/>
-          <ac:graphicFrameMkLst>
-            <pc:docMk/>
-            <pc:sldMk cId="0" sldId="391"/>
-            <ac:graphicFrameMk id="8" creationId="{00000000-0000-0000-0000-000000000000}"/>
-          </ac:graphicFrameMkLst>
-        </pc:graphicFrameChg>
-        <pc:graphicFrameChg chg="del mod replId">
-          <ac:chgData name="Lines, Todd" userId="afaf7c3a-e8aa-4568-882a-02ad8f9e19b0" providerId="ADAL" clId="{5FF5AC1B-ABA9-43D7-A1E3-2D92732CD6E2}" dt="2026-04-22T21:06:57.751" v="138"/>
-          <ac:graphicFrameMkLst>
-            <pc:docMk/>
-            <pc:sldMk cId="0" sldId="391"/>
-            <ac:graphicFrameMk id="10" creationId="{00000000-0000-0000-0000-000000000000}"/>
-          </ac:graphicFrameMkLst>
-        </pc:graphicFrameChg>
-        <pc:graphicFrameChg chg="mod">
-          <ac:chgData name="Lines, Todd" userId="afaf7c3a-e8aa-4568-882a-02ad8f9e19b0" providerId="ADAL" clId="{5FF5AC1B-ABA9-43D7-A1E3-2D92732CD6E2}" dt="2026-04-22T21:07:54.207" v="160" actId="1076"/>
-          <ac:graphicFrameMkLst>
-            <pc:docMk/>
-            <pc:sldMk cId="0" sldId="391"/>
-            <ac:graphicFrameMk id="24602" creationId="{00000000-0000-0000-0000-000000000000}"/>
-          </ac:graphicFrameMkLst>
-        </pc:graphicFrameChg>
       </pc:sldChg>
     </pc:docChg>
   </pc:docChgLst>
@@ -489,7 +308,7 @@
             <a:fld id="{DA2CA0F8-BD70-4694-BD56-6665D6FFBF3C}" type="datetimeFigureOut">
               <a:rPr lang="en-US" smtClean="0"/>
               <a:pPr/>
-              <a:t>4/22/2026</a:t>
+              <a:t>8/17/2026</a:t>
             </a:fld>
             <a:endParaRPr lang="en-US"/>
           </a:p>
@@ -867,7 +686,7 @@
                   <a:spcPct val="0"/>
                 </a:spcAft>
               </a:pPr>
-              <a:t>41</a:t>
+              <a:t>42</a:t>
             </a:fld>
             <a:endParaRPr lang="en-US" dirty="0"/>
           </a:p>
@@ -999,7 +818,7 @@
                   <a:spcPct val="0"/>
                 </a:spcAft>
               </a:pPr>
-              <a:t>42</a:t>
+              <a:t>43</a:t>
             </a:fld>
             <a:endParaRPr lang="en-US" dirty="0"/>
           </a:p>
@@ -1131,7 +950,7 @@
                   <a:spcPct val="0"/>
                 </a:spcAft>
               </a:pPr>
-              <a:t>43</a:t>
+              <a:t>44</a:t>
             </a:fld>
             <a:endParaRPr lang="en-US" dirty="0"/>
           </a:p>
@@ -1263,7 +1082,7 @@
                   <a:spcPct val="0"/>
                 </a:spcAft>
               </a:pPr>
-              <a:t>44</a:t>
+              <a:t>45</a:t>
             </a:fld>
             <a:endParaRPr lang="en-US" dirty="0"/>
           </a:p>
@@ -1462,7 +1281,7 @@
             <a:fld id="{81363FC6-F0D5-4376-9B97-08D3CD3871A3}" type="datetimeFigureOut">
               <a:rPr lang="en-US" smtClean="0"/>
               <a:pPr/>
-              <a:t>4/22/2026</a:t>
+              <a:t>8/17/2026</a:t>
             </a:fld>
             <a:endParaRPr lang="en-US"/>
           </a:p>
@@ -1627,7 +1446,7 @@
             <a:fld id="{81363FC6-F0D5-4376-9B97-08D3CD3871A3}" type="datetimeFigureOut">
               <a:rPr lang="en-US" smtClean="0"/>
               <a:pPr/>
-              <a:t>4/22/2026</a:t>
+              <a:t>8/17/2026</a:t>
             </a:fld>
             <a:endParaRPr lang="en-US"/>
           </a:p>
@@ -1802,7 +1621,7 @@
             <a:fld id="{81363FC6-F0D5-4376-9B97-08D3CD3871A3}" type="datetimeFigureOut">
               <a:rPr lang="en-US" smtClean="0"/>
               <a:pPr/>
-              <a:t>4/22/2026</a:t>
+              <a:t>8/17/2026</a:t>
             </a:fld>
             <a:endParaRPr lang="en-US"/>
           </a:p>
@@ -1967,7 +1786,7 @@
             <a:fld id="{81363FC6-F0D5-4376-9B97-08D3CD3871A3}" type="datetimeFigureOut">
               <a:rPr lang="en-US" smtClean="0"/>
               <a:pPr/>
-              <a:t>4/22/2026</a:t>
+              <a:t>8/17/2026</a:t>
             </a:fld>
             <a:endParaRPr lang="en-US"/>
           </a:p>
@@ -2209,7 +2028,7 @@
             <a:fld id="{81363FC6-F0D5-4376-9B97-08D3CD3871A3}" type="datetimeFigureOut">
               <a:rPr lang="en-US" smtClean="0"/>
               <a:pPr/>
-              <a:t>4/22/2026</a:t>
+              <a:t>8/17/2026</a:t>
             </a:fld>
             <a:endParaRPr lang="en-US"/>
           </a:p>
@@ -2491,7 +2310,7 @@
             <a:fld id="{81363FC6-F0D5-4376-9B97-08D3CD3871A3}" type="datetimeFigureOut">
               <a:rPr lang="en-US" smtClean="0"/>
               <a:pPr/>
-              <a:t>4/22/2026</a:t>
+              <a:t>8/17/2026</a:t>
             </a:fld>
             <a:endParaRPr lang="en-US"/>
           </a:p>
@@ -2907,7 +2726,7 @@
             <a:fld id="{81363FC6-F0D5-4376-9B97-08D3CD3871A3}" type="datetimeFigureOut">
               <a:rPr lang="en-US" smtClean="0"/>
               <a:pPr/>
-              <a:t>4/22/2026</a:t>
+              <a:t>8/17/2026</a:t>
             </a:fld>
             <a:endParaRPr lang="en-US"/>
           </a:p>
@@ -3021,7 +2840,7 @@
             <a:fld id="{81363FC6-F0D5-4376-9B97-08D3CD3871A3}" type="datetimeFigureOut">
               <a:rPr lang="en-US" smtClean="0"/>
               <a:pPr/>
-              <a:t>4/22/2026</a:t>
+              <a:t>8/17/2026</a:t>
             </a:fld>
             <a:endParaRPr lang="en-US"/>
           </a:p>
@@ -3113,7 +2932,7 @@
             <a:fld id="{81363FC6-F0D5-4376-9B97-08D3CD3871A3}" type="datetimeFigureOut">
               <a:rPr lang="en-US" smtClean="0"/>
               <a:pPr/>
-              <a:t>4/22/2026</a:t>
+              <a:t>8/17/2026</a:t>
             </a:fld>
             <a:endParaRPr lang="en-US"/>
           </a:p>
@@ -3385,7 +3204,7 @@
             <a:fld id="{81363FC6-F0D5-4376-9B97-08D3CD3871A3}" type="datetimeFigureOut">
               <a:rPr lang="en-US" smtClean="0"/>
               <a:pPr/>
-              <a:t>4/22/2026</a:t>
+              <a:t>8/17/2026</a:t>
             </a:fld>
             <a:endParaRPr lang="en-US"/>
           </a:p>
@@ -3634,7 +3453,7 @@
             <a:fld id="{81363FC6-F0D5-4376-9B97-08D3CD3871A3}" type="datetimeFigureOut">
               <a:rPr lang="en-US" smtClean="0"/>
               <a:pPr/>
-              <a:t>4/22/2026</a:t>
+              <a:t>8/17/2026</a:t>
             </a:fld>
             <a:endParaRPr lang="en-US"/>
           </a:p>
@@ -3842,7 +3661,7 @@
             <a:fld id="{81363FC6-F0D5-4376-9B97-08D3CD3871A3}" type="datetimeFigureOut">
               <a:rPr lang="en-US" smtClean="0"/>
               <a:pPr/>
-              <a:t>4/22/2026</a:t>
+              <a:t>8/17/2026</a:t>
             </a:fld>
             <a:endParaRPr lang="en-US"/>
           </a:p>
@@ -4284,6 +4103,86 @@
   <p:cSld>
     <p:spTree>
       <p:nvGrpSpPr>
+        <p:cNvPr id="1" name=""/>
+        <p:cNvGrpSpPr/>
+        <p:nvPr/>
+      </p:nvGrpSpPr>
+      <p:grpSpPr>
+        <a:xfrm>
+          <a:off x="0" y="0"/>
+          <a:ext cx="0" cy="0"/>
+          <a:chOff x="0" y="0"/>
+          <a:chExt cx="0" cy="0"/>
+        </a:xfrm>
+      </p:grpSpPr>
+      <p:sp>
+        <p:nvSpPr>
+          <p:cNvPr id="2" name="Title 1">
+            <a:extLst>
+              <a:ext uri="{FF2B5EF4-FFF2-40B4-BE49-F238E27FC236}">
+                <a16:creationId xmlns:a16="http://schemas.microsoft.com/office/drawing/2014/main" id="{AC05CECC-A911-41A9-CB8F-896E3C140D1E}"/>
+              </a:ext>
+            </a:extLst>
+          </p:cNvPr>
+          <p:cNvSpPr>
+            <a:spLocks noGrp="1"/>
+          </p:cNvSpPr>
+          <p:nvPr>
+            <p:ph type="title"/>
+          </p:nvPr>
+        </p:nvSpPr>
+        <p:spPr/>
+        <p:txBody>
+          <a:bodyPr/>
+          <a:lstStyle/>
+          <a:p>
+            <a:endParaRPr lang="en-US"/>
+          </a:p>
+        </p:txBody>
+      </p:sp>
+      <p:sp>
+        <p:nvSpPr>
+          <p:cNvPr id="3" name="Content Placeholder 2">
+            <a:extLst>
+              <a:ext uri="{FF2B5EF4-FFF2-40B4-BE49-F238E27FC236}">
+                <a16:creationId xmlns:a16="http://schemas.microsoft.com/office/drawing/2014/main" id="{81A691B2-768F-0B80-CC3E-B5E95360A4C1}"/>
+              </a:ext>
+            </a:extLst>
+          </p:cNvPr>
+          <p:cNvSpPr>
+            <a:spLocks noGrp="1"/>
+          </p:cNvSpPr>
+          <p:nvPr>
+            <p:ph idx="1"/>
+          </p:nvPr>
+        </p:nvSpPr>
+        <p:spPr/>
+        <p:txBody>
+          <a:bodyPr/>
+          <a:lstStyle/>
+          <a:p>
+            <a:endParaRPr lang="en-US"/>
+          </a:p>
+        </p:txBody>
+      </p:sp>
+    </p:spTree>
+    <p:extLst>
+      <p:ext uri="{BB962C8B-B14F-4D97-AF65-F5344CB8AC3E}">
+        <p14:creationId xmlns:p14="http://schemas.microsoft.com/office/powerpoint/2010/main" val="1986014694"/>
+      </p:ext>
+    </p:extLst>
+  </p:cSld>
+  <p:clrMapOvr>
+    <a:masterClrMapping/>
+  </p:clrMapOvr>
+</p:sld>
+</file>
+
+<file path=ppt/slides/slide11.xml><?xml version="1.0" encoding="utf-8"?>
+<p:sld xmlns:a="http://schemas.openxmlformats.org/drawingml/2006/main" xmlns:r="http://schemas.openxmlformats.org/officeDocument/2006/relationships" xmlns:p="http://schemas.openxmlformats.org/presentationml/2006/main">
+  <p:cSld>
+    <p:spTree>
+      <p:nvGrpSpPr>
         <p:cNvPr id="1" name="">
           <a:extLst>
             <a:ext uri="{FF2B5EF4-FFF2-40B4-BE49-F238E27FC236}">
@@ -4446,7 +4345,7 @@
             <a:fld id="{FEE5103E-6A1B-4022-ADD9-EEAD660E9795}" type="slidenum">
               <a:rPr lang="en-US" smtClean="0"/>
               <a:pPr eaLnBrk="1" hangingPunct="1"/>
-              <a:t>10</a:t>
+              <a:t>11</a:t>
             </a:fld>
             <a:endParaRPr lang="en-US"/>
           </a:p>
@@ -4713,7 +4612,7 @@
 </p:sld>
 </file>
 
-<file path=ppt/slides/slide11.xml><?xml version="1.0" encoding="utf-8"?>
+<file path=ppt/slides/slide12.xml><?xml version="1.0" encoding="utf-8"?>
 <p:sld xmlns:a="http://schemas.openxmlformats.org/drawingml/2006/main" xmlns:r="http://schemas.openxmlformats.org/officeDocument/2006/relationships" xmlns:p="http://schemas.openxmlformats.org/presentationml/2006/main">
   <p:cSld>
     <p:spTree>
@@ -4868,7 +4767,7 @@
             <a:fld id="{4E51C186-1BB2-4F1F-9C5C-C604BA7AA83F}" type="slidenum">
               <a:rPr lang="en-US" smtClean="0"/>
               <a:pPr eaLnBrk="1" hangingPunct="1"/>
-              <a:t>11</a:t>
+              <a:t>12</a:t>
             </a:fld>
             <a:endParaRPr lang="en-US"/>
           </a:p>
@@ -6426,8 +6325,8 @@
           </a:graphicData>
         </a:graphic>
       </p:graphicFrame>
-      <mc:AlternateContent xmlns:mc="http://schemas.openxmlformats.org/markup-compatibility/2006">
-        <mc:Choice xmlns:a14="http://schemas.microsoft.com/office/drawing/2010/main" Requires="a14">
+      <mc:AlternateContent xmlns:mc="http://schemas.openxmlformats.org/markup-compatibility/2006" xmlns:a14="http://schemas.microsoft.com/office/drawing/2010/main">
+        <mc:Choice Requires="a14">
           <p:sp>
             <p:nvSpPr>
               <p:cNvPr id="24597" name="Object 20"/>
@@ -6459,7 +6358,7 @@
                     <m:oMathParaPr>
                       <m:jc m:val="left"/>
                     </m:oMathParaPr>
-                    <m:oMath xmlns:m="http://schemas.openxmlformats.org/officeDocument/2006/math">
+                    <m:oMath>
                       <m:r>
                         <a:rPr lang="en-US" i="1" smtClean="0">
                           <a:solidFill>
@@ -6652,7 +6551,7 @@
             </p:txBody>
           </p:sp>
         </mc:Choice>
-        <mc:Fallback>
+        <mc:Fallback xmlns="">
           <p:sp>
             <p:nvSpPr>
               <p:cNvPr id="24597" name="Object 20"/>
@@ -6694,8 +6593,8 @@
           </p:sp>
         </mc:Fallback>
       </mc:AlternateContent>
-      <mc:AlternateContent xmlns:mc="http://schemas.openxmlformats.org/markup-compatibility/2006">
-        <mc:Choice xmlns:a14="http://schemas.microsoft.com/office/drawing/2010/main" Requires="a14">
+      <mc:AlternateContent xmlns:mc="http://schemas.openxmlformats.org/markup-compatibility/2006" xmlns:a14="http://schemas.microsoft.com/office/drawing/2010/main">
+        <mc:Choice Requires="a14">
           <p:sp>
             <p:nvSpPr>
               <p:cNvPr id="24598" name="Object 21"/>
@@ -6727,11 +6626,11 @@
                     <m:oMathParaPr>
                       <m:jc m:val="left"/>
                     </m:oMathParaPr>
-                    <m:oMath xmlns:m="http://schemas.openxmlformats.org/officeDocument/2006/math">
+                    <m:oMath>
                       <m:sSub>
                         <m:sSubPr>
                           <m:ctrlPr>
-                            <a:rPr lang="en-US" i="1" smtClean="0">
+                            <a:rPr lang="en-US" i="1">
                               <a:solidFill>
                                 <a:srgbClr val="000000"/>
                               </a:solidFill>
@@ -6829,7 +6728,7 @@
             </p:txBody>
           </p:sp>
         </mc:Choice>
-        <mc:Fallback>
+        <mc:Fallback xmlns="">
           <p:sp>
             <p:nvSpPr>
               <p:cNvPr id="24598" name="Object 21"/>
@@ -6871,8 +6770,8 @@
           </p:sp>
         </mc:Fallback>
       </mc:AlternateContent>
-      <mc:AlternateContent xmlns:mc="http://schemas.openxmlformats.org/markup-compatibility/2006">
-        <mc:Choice xmlns:a14="http://schemas.microsoft.com/office/drawing/2010/main" Requires="a14">
+      <mc:AlternateContent xmlns:mc="http://schemas.openxmlformats.org/markup-compatibility/2006" xmlns:a14="http://schemas.microsoft.com/office/drawing/2010/main">
+        <mc:Choice Requires="a14">
           <p:sp>
             <p:nvSpPr>
               <p:cNvPr id="24599" name="Object 22"/>
@@ -6904,11 +6803,11 @@
                     <m:oMathParaPr>
                       <m:jc m:val="left"/>
                     </m:oMathParaPr>
-                    <m:oMath xmlns:m="http://schemas.openxmlformats.org/officeDocument/2006/math">
+                    <m:oMath>
                       <m:sSub>
                         <m:sSubPr>
                           <m:ctrlPr>
-                            <a:rPr lang="en-US" i="1" smtClean="0">
+                            <a:rPr lang="en-US" i="1">
                               <a:solidFill>
                                 <a:srgbClr val="000000"/>
                               </a:solidFill>
@@ -6960,7 +6859,7 @@
                       <m:sSub>
                         <m:sSubPr>
                           <m:ctrlPr>
-                            <a:rPr lang="en-US" i="1" smtClean="0">
+                            <a:rPr lang="en-US" i="1">
                               <a:solidFill>
                                 <a:srgbClr val="000000"/>
                               </a:solidFill>
@@ -6999,7 +6898,7 @@
             </p:txBody>
           </p:sp>
         </mc:Choice>
-        <mc:Fallback>
+        <mc:Fallback xmlns="">
           <p:sp>
             <p:nvSpPr>
               <p:cNvPr id="24599" name="Object 22"/>
@@ -7041,8 +6940,8 @@
           </p:sp>
         </mc:Fallback>
       </mc:AlternateContent>
-      <mc:AlternateContent xmlns:mc="http://schemas.openxmlformats.org/markup-compatibility/2006">
-        <mc:Choice xmlns:a14="http://schemas.microsoft.com/office/drawing/2010/main" Requires="a14">
+      <mc:AlternateContent xmlns:mc="http://schemas.openxmlformats.org/markup-compatibility/2006" xmlns:a14="http://schemas.microsoft.com/office/drawing/2010/main">
+        <mc:Choice Requires="a14">
           <p:sp>
             <p:nvSpPr>
               <p:cNvPr id="24600" name="Object 23"/>
@@ -7074,7 +6973,7 @@
                     <m:oMathParaPr>
                       <m:jc m:val="left"/>
                     </m:oMathParaPr>
-                    <m:oMath xmlns:m="http://schemas.openxmlformats.org/officeDocument/2006/math">
+                    <m:oMath>
                       <m:r>
                         <a:rPr lang="en-US" i="1" smtClean="0">
                           <a:solidFill>
@@ -7153,7 +7052,7 @@
                       <m:func>
                         <m:funcPr>
                           <m:ctrlPr>
-                            <a:rPr lang="en-US" i="1">
+                            <a:rPr lang="en-US" i="0">
                               <a:solidFill>
                                 <a:srgbClr val="000000"/>
                               </a:solidFill>
@@ -7243,7 +7142,7 @@
             </p:txBody>
           </p:sp>
         </mc:Choice>
-        <mc:Fallback>
+        <mc:Fallback xmlns="">
           <p:sp>
             <p:nvSpPr>
               <p:cNvPr id="24600" name="Object 23"/>
@@ -7285,8 +7184,8 @@
           </p:sp>
         </mc:Fallback>
       </mc:AlternateContent>
-      <mc:AlternateContent xmlns:mc="http://schemas.openxmlformats.org/markup-compatibility/2006">
-        <mc:Choice xmlns:a14="http://schemas.microsoft.com/office/drawing/2010/main" Requires="a14">
+      <mc:AlternateContent xmlns:mc="http://schemas.openxmlformats.org/markup-compatibility/2006" xmlns:a14="http://schemas.microsoft.com/office/drawing/2010/main">
+        <mc:Choice Requires="a14">
           <p:sp>
             <p:nvSpPr>
               <p:cNvPr id="24601" name="Object 24"/>
@@ -7318,7 +7217,7 @@
                     <m:oMathParaPr>
                       <m:jc m:val="left"/>
                     </m:oMathParaPr>
-                    <m:oMath xmlns:m="http://schemas.openxmlformats.org/officeDocument/2006/math">
+                    <m:oMath>
                       <m:r>
                         <a:rPr lang="en-US" i="1" smtClean="0">
                           <a:solidFill>
@@ -7654,7 +7553,7 @@
             </p:txBody>
           </p:sp>
         </mc:Choice>
-        <mc:Fallback>
+        <mc:Fallback xmlns="">
           <p:sp>
             <p:nvSpPr>
               <p:cNvPr id="24601" name="Object 24"/>
@@ -7793,7 +7692,7 @@
 </p:sld>
 </file>
 
-<file path=ppt/slides/slide12.xml><?xml version="1.0" encoding="utf-8"?>
+<file path=ppt/slides/slide13.xml><?xml version="1.0" encoding="utf-8"?>
 <p:sld xmlns:a="http://schemas.openxmlformats.org/drawingml/2006/main" xmlns:r="http://schemas.openxmlformats.org/officeDocument/2006/relationships" xmlns:p="http://schemas.openxmlformats.org/presentationml/2006/main">
   <p:cSld>
     <p:spTree>
@@ -7876,7 +7775,7 @@
 </p:sld>
 </file>
 
-<file path=ppt/slides/slide13.xml><?xml version="1.0" encoding="utf-8"?>
+<file path=ppt/slides/slide14.xml><?xml version="1.0" encoding="utf-8"?>
 <p:sld xmlns:a="http://schemas.openxmlformats.org/drawingml/2006/main" xmlns:r="http://schemas.openxmlformats.org/officeDocument/2006/relationships" xmlns:p="http://schemas.openxmlformats.org/presentationml/2006/main">
   <p:cSld>
     <p:spTree>
@@ -8001,7 +7900,7 @@
             <a:fld id="{A450C633-03AE-4E00-8281-A488FB2231B1}" type="slidenum">
               <a:rPr lang="en-US" smtClean="0"/>
               <a:pPr/>
-              <a:t>13</a:t>
+              <a:t>14</a:t>
             </a:fld>
             <a:endParaRPr lang="en-US"/>
           </a:p>
@@ -8020,7 +7919,7 @@
 </p:sld>
 </file>
 
-<file path=ppt/slides/slide14.xml><?xml version="1.0" encoding="utf-8"?>
+<file path=ppt/slides/slide15.xml><?xml version="1.0" encoding="utf-8"?>
 <p:sld xmlns:a="http://schemas.openxmlformats.org/drawingml/2006/main" xmlns:r="http://schemas.openxmlformats.org/officeDocument/2006/relationships" xmlns:p="http://schemas.openxmlformats.org/presentationml/2006/main">
   <p:cSld>
     <p:spTree>
@@ -8150,7 +8049,7 @@
             <a:fld id="{4AD62F2E-7083-45D0-8919-2DFD6873DB31}" type="slidenum">
               <a:rPr lang="en-US" smtClean="0"/>
               <a:pPr/>
-              <a:t>14</a:t>
+              <a:t>15</a:t>
             </a:fld>
             <a:endParaRPr lang="en-US"/>
           </a:p>
@@ -8201,7 +8100,7 @@
 </p:sld>
 </file>
 
-<file path=ppt/slides/slide15.xml><?xml version="1.0" encoding="utf-8"?>
+<file path=ppt/slides/slide16.xml><?xml version="1.0" encoding="utf-8"?>
 <p:sld xmlns:a="http://schemas.openxmlformats.org/drawingml/2006/main" xmlns:r="http://schemas.openxmlformats.org/officeDocument/2006/relationships" xmlns:p="http://schemas.openxmlformats.org/presentationml/2006/main">
   <p:cSld>
     <p:spTree>
@@ -8321,7 +8220,7 @@
             <a:fld id="{4AD62F2E-7083-45D0-8919-2DFD6873DB31}" type="slidenum">
               <a:rPr lang="en-US" smtClean="0"/>
               <a:pPr/>
-              <a:t>15</a:t>
+              <a:t>16</a:t>
             </a:fld>
             <a:endParaRPr lang="en-US"/>
           </a:p>
@@ -8372,7 +8271,7 @@
 </p:sld>
 </file>
 
-<file path=ppt/slides/slide16.xml><?xml version="1.0" encoding="utf-8"?>
+<file path=ppt/slides/slide17.xml><?xml version="1.0" encoding="utf-8"?>
 <p:sld xmlns:a="http://schemas.openxmlformats.org/drawingml/2006/main" xmlns:r="http://schemas.openxmlformats.org/officeDocument/2006/relationships" xmlns:p="http://schemas.openxmlformats.org/presentationml/2006/main">
   <p:cSld>
     <p:spTree>
@@ -8614,7 +8513,7 @@
             <a:fld id="{DA3A0356-25C4-47A8-BD36-BE5A8451A2B5}" type="slidenum">
               <a:rPr lang="en-US" smtClean="0"/>
               <a:pPr/>
-              <a:t>16</a:t>
+              <a:t>17</a:t>
             </a:fld>
             <a:endParaRPr lang="en-US"/>
           </a:p>
@@ -8633,7 +8532,7 @@
 </p:sld>
 </file>
 
-<file path=ppt/slides/slide17.xml><?xml version="1.0" encoding="utf-8"?>
+<file path=ppt/slides/slide18.xml><?xml version="1.0" encoding="utf-8"?>
 <p:sld xmlns:a="http://schemas.openxmlformats.org/drawingml/2006/main" xmlns:r="http://schemas.openxmlformats.org/officeDocument/2006/relationships" xmlns:p="http://schemas.openxmlformats.org/presentationml/2006/main">
   <p:cSld>
     <p:spTree>
@@ -18393,7 +18292,7 @@
 </p:sld>
 </file>
 
-<file path=ppt/slides/slide18.xml><?xml version="1.0" encoding="utf-8"?>
+<file path=ppt/slides/slide19.xml><?xml version="1.0" encoding="utf-8"?>
 <p:sld xmlns:a="http://schemas.openxmlformats.org/drawingml/2006/main" xmlns:r="http://schemas.openxmlformats.org/officeDocument/2006/relationships" xmlns:p="http://schemas.openxmlformats.org/presentationml/2006/main">
   <p:cSld>
     <p:spTree>
@@ -18447,646 +18346,6 @@
     <p:extLst>
       <p:ext uri="{BB962C8B-B14F-4D97-AF65-F5344CB8AC3E}">
         <p14:creationId xmlns:p14="http://schemas.microsoft.com/office/powerpoint/2010/main" val="3921976112"/>
-      </p:ext>
-    </p:extLst>
-  </p:cSld>
-  <p:clrMapOvr>
-    <a:masterClrMapping/>
-  </p:clrMapOvr>
-</p:sld>
-</file>
-
-<file path=ppt/slides/slide19.xml><?xml version="1.0" encoding="utf-8"?>
-<p:sld xmlns:a="http://schemas.openxmlformats.org/drawingml/2006/main" xmlns:r="http://schemas.openxmlformats.org/officeDocument/2006/relationships" xmlns:p="http://schemas.openxmlformats.org/presentationml/2006/main">
-  <p:cSld>
-    <p:spTree>
-      <p:nvGrpSpPr>
-        <p:cNvPr id="1" name=""/>
-        <p:cNvGrpSpPr/>
-        <p:nvPr/>
-      </p:nvGrpSpPr>
-      <p:grpSpPr>
-        <a:xfrm>
-          <a:off x="0" y="0"/>
-          <a:ext cx="0" cy="0"/>
-          <a:chOff x="0" y="0"/>
-          <a:chExt cx="0" cy="0"/>
-        </a:xfrm>
-      </p:grpSpPr>
-      <p:sp>
-        <p:nvSpPr>
-          <p:cNvPr id="2" name="Title 1"/>
-          <p:cNvSpPr>
-            <a:spLocks noGrp="1"/>
-          </p:cNvSpPr>
-          <p:nvPr>
-            <p:ph type="title"/>
-          </p:nvPr>
-        </p:nvSpPr>
-        <p:spPr>
-          <a:xfrm>
-            <a:off x="457200" y="72933"/>
-            <a:ext cx="8229600" cy="1143000"/>
-          </a:xfrm>
-        </p:spPr>
-        <p:txBody>
-          <a:bodyPr/>
-          <a:lstStyle/>
-          <a:p>
-            <a:r>
-              <a:rPr lang="en-US" dirty="0"/>
-              <a:t>Question 223.2.5</a:t>
-            </a:r>
-          </a:p>
-        </p:txBody>
-      </p:sp>
-      <p:sp>
-        <p:nvSpPr>
-          <p:cNvPr id="6" name="Rectangle 3"/>
-          <p:cNvSpPr>
-            <a:spLocks noGrp="1" noChangeArrowheads="1"/>
-          </p:cNvSpPr>
-          <p:nvPr>
-            <p:ph idx="1"/>
-          </p:nvPr>
-        </p:nvSpPr>
-        <p:spPr>
-          <a:xfrm>
-            <a:off x="0" y="932983"/>
-            <a:ext cx="4921624" cy="4525963"/>
-          </a:xfrm>
-        </p:spPr>
-        <p:txBody>
-          <a:bodyPr/>
-          <a:lstStyle/>
-          <a:p>
-            <a:pPr marL="609600" indent="-609600" eaLnBrk="1" hangingPunct="1">
-              <a:buFontTx/>
-              <a:buNone/>
-            </a:pPr>
-            <a:r>
-              <a:rPr lang="en-US" dirty="0"/>
-              <a:t>In an ocean wave, what would be the most likely path a single particle traverses as the wave moves by? </a:t>
-            </a:r>
-          </a:p>
-        </p:txBody>
-      </p:sp>
-      <p:pic>
-        <p:nvPicPr>
-          <p:cNvPr id="7" name="Picture 4" descr="J5P87D0K"/>
-          <p:cNvPicPr>
-            <a:picLocks noChangeAspect="1" noChangeArrowheads="1"/>
-          </p:cNvPicPr>
-          <p:nvPr/>
-        </p:nvPicPr>
-        <p:blipFill>
-          <a:blip r:embed="rId2" cstate="print"/>
-          <a:srcRect l="15001" r="16221"/>
-          <a:stretch>
-            <a:fillRect/>
-          </a:stretch>
-        </p:blipFill>
-        <p:spPr bwMode="auto">
-          <a:xfrm>
-            <a:off x="5403271" y="1403933"/>
-            <a:ext cx="2759825" cy="1881704"/>
-          </a:xfrm>
-          <a:prstGeom prst="rect">
-            <a:avLst/>
-          </a:prstGeom>
-          <a:noFill/>
-          <a:ln w="9525">
-            <a:noFill/>
-            <a:miter lim="800000"/>
-            <a:headEnd/>
-            <a:tailEnd/>
-          </a:ln>
-        </p:spPr>
-      </p:pic>
-      <p:sp>
-        <p:nvSpPr>
-          <p:cNvPr id="8" name="Oval 7"/>
-          <p:cNvSpPr/>
-          <p:nvPr/>
-        </p:nvSpPr>
-        <p:spPr>
-          <a:xfrm>
-            <a:off x="6251169" y="1926361"/>
-            <a:ext cx="166254" cy="149629"/>
-          </a:xfrm>
-          <a:prstGeom prst="ellipse">
-            <a:avLst/>
-          </a:prstGeom>
-          <a:solidFill>
-            <a:srgbClr val="FF0000"/>
-          </a:solidFill>
-          <a:ln>
-            <a:noFill/>
-          </a:ln>
-        </p:spPr>
-        <p:style>
-          <a:lnRef idx="2">
-            <a:schemeClr val="accent1">
-              <a:shade val="50000"/>
-            </a:schemeClr>
-          </a:lnRef>
-          <a:fillRef idx="1">
-            <a:schemeClr val="accent1"/>
-          </a:fillRef>
-          <a:effectRef idx="0">
-            <a:schemeClr val="accent1"/>
-          </a:effectRef>
-          <a:fontRef idx="minor">
-            <a:schemeClr val="lt1"/>
-          </a:fontRef>
-        </p:style>
-        <p:txBody>
-          <a:bodyPr rtlCol="0" anchor="ctr"/>
-          <a:lstStyle/>
-          <a:p>
-            <a:pPr algn="ctr"/>
-            <a:endParaRPr lang="en-US"/>
-          </a:p>
-        </p:txBody>
-      </p:sp>
-      <p:cxnSp>
-        <p:nvCxnSpPr>
-          <p:cNvPr id="10" name="Straight Arrow Connector 9"/>
-          <p:cNvCxnSpPr>
-            <a:stCxn id="8" idx="6"/>
-          </p:cNvCxnSpPr>
-          <p:nvPr/>
-        </p:nvCxnSpPr>
-        <p:spPr>
-          <a:xfrm>
-            <a:off x="6417423" y="2001176"/>
-            <a:ext cx="1280161" cy="8315"/>
-          </a:xfrm>
-          <a:prstGeom prst="straightConnector1">
-            <a:avLst/>
-          </a:prstGeom>
-          <a:ln w="38100">
-            <a:solidFill>
-              <a:srgbClr val="FF0000"/>
-            </a:solidFill>
-            <a:tailEnd type="arrow"/>
-          </a:ln>
-        </p:spPr>
-        <p:style>
-          <a:lnRef idx="1">
-            <a:schemeClr val="accent1"/>
-          </a:lnRef>
-          <a:fillRef idx="0">
-            <a:schemeClr val="accent1"/>
-          </a:fillRef>
-          <a:effectRef idx="0">
-            <a:schemeClr val="accent1"/>
-          </a:effectRef>
-          <a:fontRef idx="minor">
-            <a:schemeClr val="tx1"/>
-          </a:fontRef>
-        </p:style>
-      </p:cxnSp>
-      <p:pic>
-        <p:nvPicPr>
-          <p:cNvPr id="11" name="Picture 4" descr="J5P87D0K"/>
-          <p:cNvPicPr>
-            <a:picLocks noChangeAspect="1" noChangeArrowheads="1"/>
-          </p:cNvPicPr>
-          <p:nvPr/>
-        </p:nvPicPr>
-        <p:blipFill>
-          <a:blip r:embed="rId2" cstate="print"/>
-          <a:srcRect l="15001" r="16221"/>
-          <a:stretch>
-            <a:fillRect/>
-          </a:stretch>
-        </p:blipFill>
-        <p:spPr bwMode="auto">
-          <a:xfrm>
-            <a:off x="584661" y="4282894"/>
-            <a:ext cx="2759825" cy="1881704"/>
-          </a:xfrm>
-          <a:prstGeom prst="rect">
-            <a:avLst/>
-          </a:prstGeom>
-          <a:noFill/>
-          <a:ln w="9525">
-            <a:noFill/>
-            <a:miter lim="800000"/>
-            <a:headEnd/>
-            <a:tailEnd/>
-          </a:ln>
-        </p:spPr>
-      </p:pic>
-      <p:sp>
-        <p:nvSpPr>
-          <p:cNvPr id="12" name="Oval 11"/>
-          <p:cNvSpPr/>
-          <p:nvPr/>
-        </p:nvSpPr>
-        <p:spPr>
-          <a:xfrm>
-            <a:off x="1432559" y="4805322"/>
-            <a:ext cx="166254" cy="149629"/>
-          </a:xfrm>
-          <a:prstGeom prst="ellipse">
-            <a:avLst/>
-          </a:prstGeom>
-          <a:solidFill>
-            <a:srgbClr val="FF0000"/>
-          </a:solidFill>
-          <a:ln>
-            <a:noFill/>
-          </a:ln>
-        </p:spPr>
-        <p:style>
-          <a:lnRef idx="2">
-            <a:schemeClr val="accent1">
-              <a:shade val="50000"/>
-            </a:schemeClr>
-          </a:lnRef>
-          <a:fillRef idx="1">
-            <a:schemeClr val="accent1"/>
-          </a:fillRef>
-          <a:effectRef idx="0">
-            <a:schemeClr val="accent1"/>
-          </a:effectRef>
-          <a:fontRef idx="minor">
-            <a:schemeClr val="lt1"/>
-          </a:fontRef>
-        </p:style>
-        <p:txBody>
-          <a:bodyPr rtlCol="0" anchor="ctr"/>
-          <a:lstStyle/>
-          <a:p>
-            <a:pPr algn="ctr"/>
-            <a:endParaRPr lang="en-US"/>
-          </a:p>
-        </p:txBody>
-      </p:sp>
-      <p:cxnSp>
-        <p:nvCxnSpPr>
-          <p:cNvPr id="13" name="Straight Arrow Connector 12"/>
-          <p:cNvCxnSpPr/>
-          <p:nvPr/>
-        </p:nvCxnSpPr>
-        <p:spPr>
-          <a:xfrm rot="16200000" flipH="1">
-            <a:off x="1055716" y="4877368"/>
-            <a:ext cx="914403" cy="3"/>
-          </a:xfrm>
-          <a:prstGeom prst="straightConnector1">
-            <a:avLst/>
-          </a:prstGeom>
-          <a:ln w="38100">
-            <a:solidFill>
-              <a:srgbClr val="FF0000"/>
-            </a:solidFill>
-            <a:headEnd type="arrow"/>
-            <a:tailEnd type="arrow"/>
-          </a:ln>
-        </p:spPr>
-        <p:style>
-          <a:lnRef idx="1">
-            <a:schemeClr val="accent1"/>
-          </a:lnRef>
-          <a:fillRef idx="0">
-            <a:schemeClr val="accent1"/>
-          </a:fillRef>
-          <a:effectRef idx="0">
-            <a:schemeClr val="accent1"/>
-          </a:effectRef>
-          <a:fontRef idx="minor">
-            <a:schemeClr val="tx1"/>
-          </a:fontRef>
-        </p:style>
-      </p:cxnSp>
-      <p:pic>
-        <p:nvPicPr>
-          <p:cNvPr id="18" name="Picture 4" descr="J5P87D0K"/>
-          <p:cNvPicPr>
-            <a:picLocks noChangeAspect="1" noChangeArrowheads="1"/>
-          </p:cNvPicPr>
-          <p:nvPr/>
-        </p:nvPicPr>
-        <p:blipFill>
-          <a:blip r:embed="rId2" cstate="print"/>
-          <a:srcRect l="15001" r="16221"/>
-          <a:stretch>
-            <a:fillRect/>
-          </a:stretch>
-        </p:blipFill>
-        <p:spPr bwMode="auto">
-          <a:xfrm>
-            <a:off x="5408814" y="4318918"/>
-            <a:ext cx="2759825" cy="1881704"/>
-          </a:xfrm>
-          <a:prstGeom prst="rect">
-            <a:avLst/>
-          </a:prstGeom>
-          <a:noFill/>
-          <a:ln w="9525">
-            <a:noFill/>
-            <a:miter lim="800000"/>
-            <a:headEnd/>
-            <a:tailEnd/>
-          </a:ln>
-        </p:spPr>
-      </p:pic>
-      <p:sp>
-        <p:nvSpPr>
-          <p:cNvPr id="19" name="Oval 18"/>
-          <p:cNvSpPr/>
-          <p:nvPr/>
-        </p:nvSpPr>
-        <p:spPr>
-          <a:xfrm>
-            <a:off x="6256712" y="4841346"/>
-            <a:ext cx="166254" cy="149629"/>
-          </a:xfrm>
-          <a:prstGeom prst="ellipse">
-            <a:avLst/>
-          </a:prstGeom>
-          <a:solidFill>
-            <a:srgbClr val="FF0000"/>
-          </a:solidFill>
-          <a:ln>
-            <a:noFill/>
-          </a:ln>
-        </p:spPr>
-        <p:style>
-          <a:lnRef idx="2">
-            <a:schemeClr val="accent1">
-              <a:shade val="50000"/>
-            </a:schemeClr>
-          </a:lnRef>
-          <a:fillRef idx="1">
-            <a:schemeClr val="accent1"/>
-          </a:fillRef>
-          <a:effectRef idx="0">
-            <a:schemeClr val="accent1"/>
-          </a:effectRef>
-          <a:fontRef idx="minor">
-            <a:schemeClr val="lt1"/>
-          </a:fontRef>
-        </p:style>
-        <p:txBody>
-          <a:bodyPr rtlCol="0" anchor="ctr"/>
-          <a:lstStyle/>
-          <a:p>
-            <a:pPr algn="ctr"/>
-            <a:endParaRPr lang="en-US"/>
-          </a:p>
-        </p:txBody>
-      </p:sp>
-      <p:sp>
-        <p:nvSpPr>
-          <p:cNvPr id="21" name="Arc 20"/>
-          <p:cNvSpPr/>
-          <p:nvPr/>
-        </p:nvSpPr>
-        <p:spPr>
-          <a:xfrm>
-            <a:off x="5968538" y="4569804"/>
-            <a:ext cx="731520" cy="665017"/>
-          </a:xfrm>
-          <a:prstGeom prst="arc">
-            <a:avLst>
-              <a:gd name="adj1" fmla="val 16200000"/>
-              <a:gd name="adj2" fmla="val 12516622"/>
-            </a:avLst>
-          </a:prstGeom>
-          <a:ln w="38100">
-            <a:solidFill>
-              <a:srgbClr val="FF0000"/>
-            </a:solidFill>
-            <a:headEnd type="none"/>
-            <a:tailEnd type="triangle"/>
-          </a:ln>
-        </p:spPr>
-        <p:style>
-          <a:lnRef idx="1">
-            <a:schemeClr val="accent1"/>
-          </a:lnRef>
-          <a:fillRef idx="0">
-            <a:schemeClr val="accent1"/>
-          </a:fillRef>
-          <a:effectRef idx="0">
-            <a:schemeClr val="accent1"/>
-          </a:effectRef>
-          <a:fontRef idx="minor">
-            <a:schemeClr val="tx1"/>
-          </a:fontRef>
-        </p:style>
-        <p:txBody>
-          <a:bodyPr rtlCol="0" anchor="ctr"/>
-          <a:lstStyle/>
-          <a:p>
-            <a:pPr algn="ctr"/>
-            <a:endParaRPr lang="en-US"/>
-          </a:p>
-        </p:txBody>
-      </p:sp>
-      <p:cxnSp>
-        <p:nvCxnSpPr>
-          <p:cNvPr id="22" name="Straight Arrow Connector 21"/>
-          <p:cNvCxnSpPr/>
-          <p:nvPr/>
-        </p:nvCxnSpPr>
-        <p:spPr>
-          <a:xfrm>
-            <a:off x="6054434" y="1122798"/>
-            <a:ext cx="1280161" cy="8315"/>
-          </a:xfrm>
-          <a:prstGeom prst="straightConnector1">
-            <a:avLst/>
-          </a:prstGeom>
-          <a:ln w="38100">
-            <a:solidFill>
-              <a:schemeClr val="accent1"/>
-            </a:solidFill>
-            <a:tailEnd type="arrow"/>
-          </a:ln>
-        </p:spPr>
-        <p:style>
-          <a:lnRef idx="1">
-            <a:schemeClr val="accent1"/>
-          </a:lnRef>
-          <a:fillRef idx="0">
-            <a:schemeClr val="accent1"/>
-          </a:fillRef>
-          <a:effectRef idx="0">
-            <a:schemeClr val="accent1"/>
-          </a:effectRef>
-          <a:fontRef idx="minor">
-            <a:schemeClr val="tx1"/>
-          </a:fontRef>
-        </p:style>
-      </p:cxnSp>
-      <p:cxnSp>
-        <p:nvCxnSpPr>
-          <p:cNvPr id="23" name="Straight Arrow Connector 22"/>
-          <p:cNvCxnSpPr/>
-          <p:nvPr/>
-        </p:nvCxnSpPr>
-        <p:spPr>
-          <a:xfrm>
-            <a:off x="6123708" y="4118140"/>
-            <a:ext cx="1280161" cy="8315"/>
-          </a:xfrm>
-          <a:prstGeom prst="straightConnector1">
-            <a:avLst/>
-          </a:prstGeom>
-          <a:ln w="38100">
-            <a:solidFill>
-              <a:schemeClr val="accent1"/>
-            </a:solidFill>
-            <a:tailEnd type="arrow"/>
-          </a:ln>
-        </p:spPr>
-        <p:style>
-          <a:lnRef idx="1">
-            <a:schemeClr val="accent1"/>
-          </a:lnRef>
-          <a:fillRef idx="0">
-            <a:schemeClr val="accent1"/>
-          </a:fillRef>
-          <a:effectRef idx="0">
-            <a:schemeClr val="accent1"/>
-          </a:effectRef>
-          <a:fontRef idx="minor">
-            <a:schemeClr val="tx1"/>
-          </a:fontRef>
-        </p:style>
-      </p:cxnSp>
-      <p:cxnSp>
-        <p:nvCxnSpPr>
-          <p:cNvPr id="24" name="Straight Arrow Connector 23"/>
-          <p:cNvCxnSpPr/>
-          <p:nvPr/>
-        </p:nvCxnSpPr>
-        <p:spPr>
-          <a:xfrm>
-            <a:off x="1205345" y="4120909"/>
-            <a:ext cx="1280161" cy="8315"/>
-          </a:xfrm>
-          <a:prstGeom prst="straightConnector1">
-            <a:avLst/>
-          </a:prstGeom>
-          <a:ln w="38100">
-            <a:solidFill>
-              <a:schemeClr val="accent1"/>
-            </a:solidFill>
-            <a:tailEnd type="arrow"/>
-          </a:ln>
-        </p:spPr>
-        <p:style>
-          <a:lnRef idx="1">
-            <a:schemeClr val="accent1"/>
-          </a:lnRef>
-          <a:fillRef idx="0">
-            <a:schemeClr val="accent1"/>
-          </a:fillRef>
-          <a:effectRef idx="0">
-            <a:schemeClr val="accent1"/>
-          </a:effectRef>
-          <a:fontRef idx="minor">
-            <a:schemeClr val="tx1"/>
-          </a:fontRef>
-        </p:style>
-      </p:cxnSp>
-      <p:sp>
-        <p:nvSpPr>
-          <p:cNvPr id="25" name="TextBox 24"/>
-          <p:cNvSpPr txBox="1"/>
-          <p:nvPr/>
-        </p:nvSpPr>
-        <p:spPr>
-          <a:xfrm>
-            <a:off x="1745672" y="6165842"/>
-            <a:ext cx="338554" cy="369332"/>
-          </a:xfrm>
-          <a:prstGeom prst="rect">
-            <a:avLst/>
-          </a:prstGeom>
-          <a:noFill/>
-        </p:spPr>
-        <p:txBody>
-          <a:bodyPr wrap="none" rtlCol="0">
-            <a:spAutoFit/>
-          </a:bodyPr>
-          <a:lstStyle/>
-          <a:p>
-            <a:r>
-              <a:rPr lang="en-US" dirty="0"/>
-              <a:t>A</a:t>
-            </a:r>
-          </a:p>
-        </p:txBody>
-      </p:sp>
-      <p:sp>
-        <p:nvSpPr>
-          <p:cNvPr id="26" name="TextBox 25"/>
-          <p:cNvSpPr txBox="1"/>
-          <p:nvPr/>
-        </p:nvSpPr>
-        <p:spPr>
-          <a:xfrm>
-            <a:off x="6553199" y="3309045"/>
-            <a:ext cx="338554" cy="369332"/>
-          </a:xfrm>
-          <a:prstGeom prst="rect">
-            <a:avLst/>
-          </a:prstGeom>
-          <a:noFill/>
-        </p:spPr>
-        <p:txBody>
-          <a:bodyPr wrap="none" rtlCol="0">
-            <a:spAutoFit/>
-          </a:bodyPr>
-          <a:lstStyle/>
-          <a:p>
-            <a:r>
-              <a:rPr lang="en-US" dirty="0"/>
-              <a:t>B</a:t>
-            </a:r>
-          </a:p>
-        </p:txBody>
-      </p:sp>
-      <p:sp>
-        <p:nvSpPr>
-          <p:cNvPr id="27" name="TextBox 26"/>
-          <p:cNvSpPr txBox="1"/>
-          <p:nvPr/>
-        </p:nvSpPr>
-        <p:spPr>
-          <a:xfrm>
-            <a:off x="6555974" y="6187945"/>
-            <a:ext cx="351378" cy="369332"/>
-          </a:xfrm>
-          <a:prstGeom prst="rect">
-            <a:avLst/>
-          </a:prstGeom>
-          <a:noFill/>
-        </p:spPr>
-        <p:txBody>
-          <a:bodyPr wrap="none" rtlCol="0">
-            <a:spAutoFit/>
-          </a:bodyPr>
-          <a:lstStyle/>
-          <a:p>
-            <a:r>
-              <a:rPr lang="en-US" dirty="0"/>
-              <a:t>C</a:t>
-            </a:r>
-          </a:p>
-        </p:txBody>
-      </p:sp>
-    </p:spTree>
-    <p:extLst>
-      <p:ext uri="{BB962C8B-B14F-4D97-AF65-F5344CB8AC3E}">
-        <p14:creationId xmlns:p14="http://schemas.microsoft.com/office/powerpoint/2010/main" val="1479243362"/>
       </p:ext>
     </p:extLst>
   </p:cSld>
@@ -19525,6 +18784,646 @@
             <p:ph type="title"/>
           </p:nvPr>
         </p:nvSpPr>
+        <p:spPr>
+          <a:xfrm>
+            <a:off x="457200" y="72933"/>
+            <a:ext cx="8229600" cy="1143000"/>
+          </a:xfrm>
+        </p:spPr>
+        <p:txBody>
+          <a:bodyPr/>
+          <a:lstStyle/>
+          <a:p>
+            <a:r>
+              <a:rPr lang="en-US" dirty="0"/>
+              <a:t>Question 223.2.5</a:t>
+            </a:r>
+          </a:p>
+        </p:txBody>
+      </p:sp>
+      <p:sp>
+        <p:nvSpPr>
+          <p:cNvPr id="6" name="Rectangle 3"/>
+          <p:cNvSpPr>
+            <a:spLocks noGrp="1" noChangeArrowheads="1"/>
+          </p:cNvSpPr>
+          <p:nvPr>
+            <p:ph idx="1"/>
+          </p:nvPr>
+        </p:nvSpPr>
+        <p:spPr>
+          <a:xfrm>
+            <a:off x="0" y="932983"/>
+            <a:ext cx="4921624" cy="4525963"/>
+          </a:xfrm>
+        </p:spPr>
+        <p:txBody>
+          <a:bodyPr/>
+          <a:lstStyle/>
+          <a:p>
+            <a:pPr marL="609600" indent="-609600" eaLnBrk="1" hangingPunct="1">
+              <a:buFontTx/>
+              <a:buNone/>
+            </a:pPr>
+            <a:r>
+              <a:rPr lang="en-US" dirty="0"/>
+              <a:t>In an ocean wave, what would be the most likely path a single particle traverses as the wave moves by? </a:t>
+            </a:r>
+          </a:p>
+        </p:txBody>
+      </p:sp>
+      <p:pic>
+        <p:nvPicPr>
+          <p:cNvPr id="7" name="Picture 4" descr="J5P87D0K"/>
+          <p:cNvPicPr>
+            <a:picLocks noChangeAspect="1" noChangeArrowheads="1"/>
+          </p:cNvPicPr>
+          <p:nvPr/>
+        </p:nvPicPr>
+        <p:blipFill>
+          <a:blip r:embed="rId2" cstate="print"/>
+          <a:srcRect l="15001" r="16221"/>
+          <a:stretch>
+            <a:fillRect/>
+          </a:stretch>
+        </p:blipFill>
+        <p:spPr bwMode="auto">
+          <a:xfrm>
+            <a:off x="5403271" y="1403933"/>
+            <a:ext cx="2759825" cy="1881704"/>
+          </a:xfrm>
+          <a:prstGeom prst="rect">
+            <a:avLst/>
+          </a:prstGeom>
+          <a:noFill/>
+          <a:ln w="9525">
+            <a:noFill/>
+            <a:miter lim="800000"/>
+            <a:headEnd/>
+            <a:tailEnd/>
+          </a:ln>
+        </p:spPr>
+      </p:pic>
+      <p:sp>
+        <p:nvSpPr>
+          <p:cNvPr id="8" name="Oval 7"/>
+          <p:cNvSpPr/>
+          <p:nvPr/>
+        </p:nvSpPr>
+        <p:spPr>
+          <a:xfrm>
+            <a:off x="6251169" y="1926361"/>
+            <a:ext cx="166254" cy="149629"/>
+          </a:xfrm>
+          <a:prstGeom prst="ellipse">
+            <a:avLst/>
+          </a:prstGeom>
+          <a:solidFill>
+            <a:srgbClr val="FF0000"/>
+          </a:solidFill>
+          <a:ln>
+            <a:noFill/>
+          </a:ln>
+        </p:spPr>
+        <p:style>
+          <a:lnRef idx="2">
+            <a:schemeClr val="accent1">
+              <a:shade val="50000"/>
+            </a:schemeClr>
+          </a:lnRef>
+          <a:fillRef idx="1">
+            <a:schemeClr val="accent1"/>
+          </a:fillRef>
+          <a:effectRef idx="0">
+            <a:schemeClr val="accent1"/>
+          </a:effectRef>
+          <a:fontRef idx="minor">
+            <a:schemeClr val="lt1"/>
+          </a:fontRef>
+        </p:style>
+        <p:txBody>
+          <a:bodyPr rtlCol="0" anchor="ctr"/>
+          <a:lstStyle/>
+          <a:p>
+            <a:pPr algn="ctr"/>
+            <a:endParaRPr lang="en-US"/>
+          </a:p>
+        </p:txBody>
+      </p:sp>
+      <p:cxnSp>
+        <p:nvCxnSpPr>
+          <p:cNvPr id="10" name="Straight Arrow Connector 9"/>
+          <p:cNvCxnSpPr>
+            <a:stCxn id="8" idx="6"/>
+          </p:cNvCxnSpPr>
+          <p:nvPr/>
+        </p:nvCxnSpPr>
+        <p:spPr>
+          <a:xfrm>
+            <a:off x="6417423" y="2001176"/>
+            <a:ext cx="1280161" cy="8315"/>
+          </a:xfrm>
+          <a:prstGeom prst="straightConnector1">
+            <a:avLst/>
+          </a:prstGeom>
+          <a:ln w="38100">
+            <a:solidFill>
+              <a:srgbClr val="FF0000"/>
+            </a:solidFill>
+            <a:tailEnd type="arrow"/>
+          </a:ln>
+        </p:spPr>
+        <p:style>
+          <a:lnRef idx="1">
+            <a:schemeClr val="accent1"/>
+          </a:lnRef>
+          <a:fillRef idx="0">
+            <a:schemeClr val="accent1"/>
+          </a:fillRef>
+          <a:effectRef idx="0">
+            <a:schemeClr val="accent1"/>
+          </a:effectRef>
+          <a:fontRef idx="minor">
+            <a:schemeClr val="tx1"/>
+          </a:fontRef>
+        </p:style>
+      </p:cxnSp>
+      <p:pic>
+        <p:nvPicPr>
+          <p:cNvPr id="11" name="Picture 4" descr="J5P87D0K"/>
+          <p:cNvPicPr>
+            <a:picLocks noChangeAspect="1" noChangeArrowheads="1"/>
+          </p:cNvPicPr>
+          <p:nvPr/>
+        </p:nvPicPr>
+        <p:blipFill>
+          <a:blip r:embed="rId2" cstate="print"/>
+          <a:srcRect l="15001" r="16221"/>
+          <a:stretch>
+            <a:fillRect/>
+          </a:stretch>
+        </p:blipFill>
+        <p:spPr bwMode="auto">
+          <a:xfrm>
+            <a:off x="584661" y="4282894"/>
+            <a:ext cx="2759825" cy="1881704"/>
+          </a:xfrm>
+          <a:prstGeom prst="rect">
+            <a:avLst/>
+          </a:prstGeom>
+          <a:noFill/>
+          <a:ln w="9525">
+            <a:noFill/>
+            <a:miter lim="800000"/>
+            <a:headEnd/>
+            <a:tailEnd/>
+          </a:ln>
+        </p:spPr>
+      </p:pic>
+      <p:sp>
+        <p:nvSpPr>
+          <p:cNvPr id="12" name="Oval 11"/>
+          <p:cNvSpPr/>
+          <p:nvPr/>
+        </p:nvSpPr>
+        <p:spPr>
+          <a:xfrm>
+            <a:off x="1432559" y="4805322"/>
+            <a:ext cx="166254" cy="149629"/>
+          </a:xfrm>
+          <a:prstGeom prst="ellipse">
+            <a:avLst/>
+          </a:prstGeom>
+          <a:solidFill>
+            <a:srgbClr val="FF0000"/>
+          </a:solidFill>
+          <a:ln>
+            <a:noFill/>
+          </a:ln>
+        </p:spPr>
+        <p:style>
+          <a:lnRef idx="2">
+            <a:schemeClr val="accent1">
+              <a:shade val="50000"/>
+            </a:schemeClr>
+          </a:lnRef>
+          <a:fillRef idx="1">
+            <a:schemeClr val="accent1"/>
+          </a:fillRef>
+          <a:effectRef idx="0">
+            <a:schemeClr val="accent1"/>
+          </a:effectRef>
+          <a:fontRef idx="minor">
+            <a:schemeClr val="lt1"/>
+          </a:fontRef>
+        </p:style>
+        <p:txBody>
+          <a:bodyPr rtlCol="0" anchor="ctr"/>
+          <a:lstStyle/>
+          <a:p>
+            <a:pPr algn="ctr"/>
+            <a:endParaRPr lang="en-US"/>
+          </a:p>
+        </p:txBody>
+      </p:sp>
+      <p:cxnSp>
+        <p:nvCxnSpPr>
+          <p:cNvPr id="13" name="Straight Arrow Connector 12"/>
+          <p:cNvCxnSpPr/>
+          <p:nvPr/>
+        </p:nvCxnSpPr>
+        <p:spPr>
+          <a:xfrm rot="16200000" flipH="1">
+            <a:off x="1055716" y="4877368"/>
+            <a:ext cx="914403" cy="3"/>
+          </a:xfrm>
+          <a:prstGeom prst="straightConnector1">
+            <a:avLst/>
+          </a:prstGeom>
+          <a:ln w="38100">
+            <a:solidFill>
+              <a:srgbClr val="FF0000"/>
+            </a:solidFill>
+            <a:headEnd type="arrow"/>
+            <a:tailEnd type="arrow"/>
+          </a:ln>
+        </p:spPr>
+        <p:style>
+          <a:lnRef idx="1">
+            <a:schemeClr val="accent1"/>
+          </a:lnRef>
+          <a:fillRef idx="0">
+            <a:schemeClr val="accent1"/>
+          </a:fillRef>
+          <a:effectRef idx="0">
+            <a:schemeClr val="accent1"/>
+          </a:effectRef>
+          <a:fontRef idx="minor">
+            <a:schemeClr val="tx1"/>
+          </a:fontRef>
+        </p:style>
+      </p:cxnSp>
+      <p:pic>
+        <p:nvPicPr>
+          <p:cNvPr id="18" name="Picture 4" descr="J5P87D0K"/>
+          <p:cNvPicPr>
+            <a:picLocks noChangeAspect="1" noChangeArrowheads="1"/>
+          </p:cNvPicPr>
+          <p:nvPr/>
+        </p:nvPicPr>
+        <p:blipFill>
+          <a:blip r:embed="rId2" cstate="print"/>
+          <a:srcRect l="15001" r="16221"/>
+          <a:stretch>
+            <a:fillRect/>
+          </a:stretch>
+        </p:blipFill>
+        <p:spPr bwMode="auto">
+          <a:xfrm>
+            <a:off x="5408814" y="4318918"/>
+            <a:ext cx="2759825" cy="1881704"/>
+          </a:xfrm>
+          <a:prstGeom prst="rect">
+            <a:avLst/>
+          </a:prstGeom>
+          <a:noFill/>
+          <a:ln w="9525">
+            <a:noFill/>
+            <a:miter lim="800000"/>
+            <a:headEnd/>
+            <a:tailEnd/>
+          </a:ln>
+        </p:spPr>
+      </p:pic>
+      <p:sp>
+        <p:nvSpPr>
+          <p:cNvPr id="19" name="Oval 18"/>
+          <p:cNvSpPr/>
+          <p:nvPr/>
+        </p:nvSpPr>
+        <p:spPr>
+          <a:xfrm>
+            <a:off x="6256712" y="4841346"/>
+            <a:ext cx="166254" cy="149629"/>
+          </a:xfrm>
+          <a:prstGeom prst="ellipse">
+            <a:avLst/>
+          </a:prstGeom>
+          <a:solidFill>
+            <a:srgbClr val="FF0000"/>
+          </a:solidFill>
+          <a:ln>
+            <a:noFill/>
+          </a:ln>
+        </p:spPr>
+        <p:style>
+          <a:lnRef idx="2">
+            <a:schemeClr val="accent1">
+              <a:shade val="50000"/>
+            </a:schemeClr>
+          </a:lnRef>
+          <a:fillRef idx="1">
+            <a:schemeClr val="accent1"/>
+          </a:fillRef>
+          <a:effectRef idx="0">
+            <a:schemeClr val="accent1"/>
+          </a:effectRef>
+          <a:fontRef idx="minor">
+            <a:schemeClr val="lt1"/>
+          </a:fontRef>
+        </p:style>
+        <p:txBody>
+          <a:bodyPr rtlCol="0" anchor="ctr"/>
+          <a:lstStyle/>
+          <a:p>
+            <a:pPr algn="ctr"/>
+            <a:endParaRPr lang="en-US"/>
+          </a:p>
+        </p:txBody>
+      </p:sp>
+      <p:sp>
+        <p:nvSpPr>
+          <p:cNvPr id="21" name="Arc 20"/>
+          <p:cNvSpPr/>
+          <p:nvPr/>
+        </p:nvSpPr>
+        <p:spPr>
+          <a:xfrm>
+            <a:off x="5968538" y="4569804"/>
+            <a:ext cx="731520" cy="665017"/>
+          </a:xfrm>
+          <a:prstGeom prst="arc">
+            <a:avLst>
+              <a:gd name="adj1" fmla="val 16200000"/>
+              <a:gd name="adj2" fmla="val 12516622"/>
+            </a:avLst>
+          </a:prstGeom>
+          <a:ln w="38100">
+            <a:solidFill>
+              <a:srgbClr val="FF0000"/>
+            </a:solidFill>
+            <a:headEnd type="none"/>
+            <a:tailEnd type="triangle"/>
+          </a:ln>
+        </p:spPr>
+        <p:style>
+          <a:lnRef idx="1">
+            <a:schemeClr val="accent1"/>
+          </a:lnRef>
+          <a:fillRef idx="0">
+            <a:schemeClr val="accent1"/>
+          </a:fillRef>
+          <a:effectRef idx="0">
+            <a:schemeClr val="accent1"/>
+          </a:effectRef>
+          <a:fontRef idx="minor">
+            <a:schemeClr val="tx1"/>
+          </a:fontRef>
+        </p:style>
+        <p:txBody>
+          <a:bodyPr rtlCol="0" anchor="ctr"/>
+          <a:lstStyle/>
+          <a:p>
+            <a:pPr algn="ctr"/>
+            <a:endParaRPr lang="en-US"/>
+          </a:p>
+        </p:txBody>
+      </p:sp>
+      <p:cxnSp>
+        <p:nvCxnSpPr>
+          <p:cNvPr id="22" name="Straight Arrow Connector 21"/>
+          <p:cNvCxnSpPr/>
+          <p:nvPr/>
+        </p:nvCxnSpPr>
+        <p:spPr>
+          <a:xfrm>
+            <a:off x="6054434" y="1122798"/>
+            <a:ext cx="1280161" cy="8315"/>
+          </a:xfrm>
+          <a:prstGeom prst="straightConnector1">
+            <a:avLst/>
+          </a:prstGeom>
+          <a:ln w="38100">
+            <a:solidFill>
+              <a:schemeClr val="accent1"/>
+            </a:solidFill>
+            <a:tailEnd type="arrow"/>
+          </a:ln>
+        </p:spPr>
+        <p:style>
+          <a:lnRef idx="1">
+            <a:schemeClr val="accent1"/>
+          </a:lnRef>
+          <a:fillRef idx="0">
+            <a:schemeClr val="accent1"/>
+          </a:fillRef>
+          <a:effectRef idx="0">
+            <a:schemeClr val="accent1"/>
+          </a:effectRef>
+          <a:fontRef idx="minor">
+            <a:schemeClr val="tx1"/>
+          </a:fontRef>
+        </p:style>
+      </p:cxnSp>
+      <p:cxnSp>
+        <p:nvCxnSpPr>
+          <p:cNvPr id="23" name="Straight Arrow Connector 22"/>
+          <p:cNvCxnSpPr/>
+          <p:nvPr/>
+        </p:nvCxnSpPr>
+        <p:spPr>
+          <a:xfrm>
+            <a:off x="6123708" y="4118140"/>
+            <a:ext cx="1280161" cy="8315"/>
+          </a:xfrm>
+          <a:prstGeom prst="straightConnector1">
+            <a:avLst/>
+          </a:prstGeom>
+          <a:ln w="38100">
+            <a:solidFill>
+              <a:schemeClr val="accent1"/>
+            </a:solidFill>
+            <a:tailEnd type="arrow"/>
+          </a:ln>
+        </p:spPr>
+        <p:style>
+          <a:lnRef idx="1">
+            <a:schemeClr val="accent1"/>
+          </a:lnRef>
+          <a:fillRef idx="0">
+            <a:schemeClr val="accent1"/>
+          </a:fillRef>
+          <a:effectRef idx="0">
+            <a:schemeClr val="accent1"/>
+          </a:effectRef>
+          <a:fontRef idx="minor">
+            <a:schemeClr val="tx1"/>
+          </a:fontRef>
+        </p:style>
+      </p:cxnSp>
+      <p:cxnSp>
+        <p:nvCxnSpPr>
+          <p:cNvPr id="24" name="Straight Arrow Connector 23"/>
+          <p:cNvCxnSpPr/>
+          <p:nvPr/>
+        </p:nvCxnSpPr>
+        <p:spPr>
+          <a:xfrm>
+            <a:off x="1205345" y="4120909"/>
+            <a:ext cx="1280161" cy="8315"/>
+          </a:xfrm>
+          <a:prstGeom prst="straightConnector1">
+            <a:avLst/>
+          </a:prstGeom>
+          <a:ln w="38100">
+            <a:solidFill>
+              <a:schemeClr val="accent1"/>
+            </a:solidFill>
+            <a:tailEnd type="arrow"/>
+          </a:ln>
+        </p:spPr>
+        <p:style>
+          <a:lnRef idx="1">
+            <a:schemeClr val="accent1"/>
+          </a:lnRef>
+          <a:fillRef idx="0">
+            <a:schemeClr val="accent1"/>
+          </a:fillRef>
+          <a:effectRef idx="0">
+            <a:schemeClr val="accent1"/>
+          </a:effectRef>
+          <a:fontRef idx="minor">
+            <a:schemeClr val="tx1"/>
+          </a:fontRef>
+        </p:style>
+      </p:cxnSp>
+      <p:sp>
+        <p:nvSpPr>
+          <p:cNvPr id="25" name="TextBox 24"/>
+          <p:cNvSpPr txBox="1"/>
+          <p:nvPr/>
+        </p:nvSpPr>
+        <p:spPr>
+          <a:xfrm>
+            <a:off x="1745672" y="6165842"/>
+            <a:ext cx="338554" cy="369332"/>
+          </a:xfrm>
+          <a:prstGeom prst="rect">
+            <a:avLst/>
+          </a:prstGeom>
+          <a:noFill/>
+        </p:spPr>
+        <p:txBody>
+          <a:bodyPr wrap="none" rtlCol="0">
+            <a:spAutoFit/>
+          </a:bodyPr>
+          <a:lstStyle/>
+          <a:p>
+            <a:r>
+              <a:rPr lang="en-US" dirty="0"/>
+              <a:t>A</a:t>
+            </a:r>
+          </a:p>
+        </p:txBody>
+      </p:sp>
+      <p:sp>
+        <p:nvSpPr>
+          <p:cNvPr id="26" name="TextBox 25"/>
+          <p:cNvSpPr txBox="1"/>
+          <p:nvPr/>
+        </p:nvSpPr>
+        <p:spPr>
+          <a:xfrm>
+            <a:off x="6553199" y="3309045"/>
+            <a:ext cx="338554" cy="369332"/>
+          </a:xfrm>
+          <a:prstGeom prst="rect">
+            <a:avLst/>
+          </a:prstGeom>
+          <a:noFill/>
+        </p:spPr>
+        <p:txBody>
+          <a:bodyPr wrap="none" rtlCol="0">
+            <a:spAutoFit/>
+          </a:bodyPr>
+          <a:lstStyle/>
+          <a:p>
+            <a:r>
+              <a:rPr lang="en-US" dirty="0"/>
+              <a:t>B</a:t>
+            </a:r>
+          </a:p>
+        </p:txBody>
+      </p:sp>
+      <p:sp>
+        <p:nvSpPr>
+          <p:cNvPr id="27" name="TextBox 26"/>
+          <p:cNvSpPr txBox="1"/>
+          <p:nvPr/>
+        </p:nvSpPr>
+        <p:spPr>
+          <a:xfrm>
+            <a:off x="6555974" y="6187945"/>
+            <a:ext cx="351378" cy="369332"/>
+          </a:xfrm>
+          <a:prstGeom prst="rect">
+            <a:avLst/>
+          </a:prstGeom>
+          <a:noFill/>
+        </p:spPr>
+        <p:txBody>
+          <a:bodyPr wrap="none" rtlCol="0">
+            <a:spAutoFit/>
+          </a:bodyPr>
+          <a:lstStyle/>
+          <a:p>
+            <a:r>
+              <a:rPr lang="en-US" dirty="0"/>
+              <a:t>C</a:t>
+            </a:r>
+          </a:p>
+        </p:txBody>
+      </p:sp>
+    </p:spTree>
+    <p:extLst>
+      <p:ext uri="{BB962C8B-B14F-4D97-AF65-F5344CB8AC3E}">
+        <p14:creationId xmlns:p14="http://schemas.microsoft.com/office/powerpoint/2010/main" val="1479243362"/>
+      </p:ext>
+    </p:extLst>
+  </p:cSld>
+  <p:clrMapOvr>
+    <a:masterClrMapping/>
+  </p:clrMapOvr>
+</p:sld>
+</file>
+
+<file path=ppt/slides/slide21.xml><?xml version="1.0" encoding="utf-8"?>
+<p:sld xmlns:a="http://schemas.openxmlformats.org/drawingml/2006/main" xmlns:r="http://schemas.openxmlformats.org/officeDocument/2006/relationships" xmlns:p="http://schemas.openxmlformats.org/presentationml/2006/main">
+  <p:cSld>
+    <p:spTree>
+      <p:nvGrpSpPr>
+        <p:cNvPr id="1" name=""/>
+        <p:cNvGrpSpPr/>
+        <p:nvPr/>
+      </p:nvGrpSpPr>
+      <p:grpSpPr>
+        <a:xfrm>
+          <a:off x="0" y="0"/>
+          <a:ext cx="0" cy="0"/>
+          <a:chOff x="0" y="0"/>
+          <a:chExt cx="0" cy="0"/>
+        </a:xfrm>
+      </p:grpSpPr>
+      <p:sp>
+        <p:nvSpPr>
+          <p:cNvPr id="2" name="Title 1"/>
+          <p:cNvSpPr>
+            <a:spLocks noGrp="1"/>
+          </p:cNvSpPr>
+          <p:nvPr>
+            <p:ph type="title"/>
+          </p:nvPr>
+        </p:nvSpPr>
         <p:spPr/>
         <p:txBody>
           <a:bodyPr/>
@@ -19623,7 +19522,7 @@
 </p:sld>
 </file>
 
-<file path=ppt/slides/slide21.xml><?xml version="1.0" encoding="utf-8"?>
+<file path=ppt/slides/slide22.xml><?xml version="1.0" encoding="utf-8"?>
 <p:sld xmlns:a="http://schemas.openxmlformats.org/drawingml/2006/main" xmlns:r="http://schemas.openxmlformats.org/officeDocument/2006/relationships" xmlns:p="http://schemas.openxmlformats.org/presentationml/2006/main">
   <p:cSld>
     <p:spTree>
@@ -19701,14 +19600,11 @@
                 </a:pPr>
                 <a14:m>
                   <m:oMathPara xmlns:m="http://schemas.openxmlformats.org/officeDocument/2006/math">
-                    <m:oMathParaPr>
-                      <m:jc m:val="centerGroup"/>
-                    </m:oMathParaPr>
-                    <m:oMath xmlns:m="http://schemas.openxmlformats.org/officeDocument/2006/math">
+                    <m:oMath>
                       <m:f>
                         <m:fPr>
                           <m:ctrlPr>
-                            <a:rPr lang="en-US" i="1" smtClean="0">
+                            <a:rPr lang="en-US" b="0" i="1" smtClean="0">
                               <a:latin typeface="Cambria Math" panose="02040503050406030204" pitchFamily="18" charset="0"/>
                             </a:rPr>
                           </m:ctrlPr>
@@ -19851,7 +19747,7 @@
 </p:sld>
 </file>
 
-<file path=ppt/slides/slide22.xml><?xml version="1.0" encoding="utf-8"?>
+<file path=ppt/slides/slide23.xml><?xml version="1.0" encoding="utf-8"?>
 <p:sld xmlns:a="http://schemas.openxmlformats.org/drawingml/2006/main" xmlns:r="http://schemas.openxmlformats.org/officeDocument/2006/relationships" xmlns:p="http://schemas.openxmlformats.org/presentationml/2006/main">
   <p:cSld>
     <p:spTree>
@@ -19929,14 +19825,11 @@
                 </a:pPr>
                 <a14:m>
                   <m:oMathPara xmlns:m="http://schemas.openxmlformats.org/officeDocument/2006/math">
-                    <m:oMathParaPr>
-                      <m:jc m:val="centerGroup"/>
-                    </m:oMathParaPr>
-                    <m:oMath xmlns:m="http://schemas.openxmlformats.org/officeDocument/2006/math">
+                    <m:oMath>
                       <m:f>
                         <m:fPr>
                           <m:ctrlPr>
-                            <a:rPr lang="en-US" i="1" smtClean="0">
+                            <a:rPr lang="en-US" b="0" i="1" smtClean="0">
                               <a:latin typeface="Cambria Math" panose="02040503050406030204" pitchFamily="18" charset="0"/>
                             </a:rPr>
                           </m:ctrlPr>
@@ -20083,7 +19976,7 @@
 </p:sld>
 </file>
 
-<file path=ppt/slides/slide23.xml><?xml version="1.0" encoding="utf-8"?>
+<file path=ppt/slides/slide24.xml><?xml version="1.0" encoding="utf-8"?>
 <p:sld xmlns:a="http://schemas.openxmlformats.org/drawingml/2006/main" xmlns:r="http://schemas.openxmlformats.org/officeDocument/2006/relationships" xmlns:p="http://schemas.openxmlformats.org/presentationml/2006/main">
   <p:cSld>
     <p:spTree>
@@ -20310,7 +20203,7 @@
 </p:sld>
 </file>
 
-<file path=ppt/slides/slide24.xml><?xml version="1.0" encoding="utf-8"?>
+<file path=ppt/slides/slide25.xml><?xml version="1.0" encoding="utf-8"?>
 <p:sld xmlns:a="http://schemas.openxmlformats.org/drawingml/2006/main" xmlns:r="http://schemas.openxmlformats.org/officeDocument/2006/relationships" xmlns:p="http://schemas.openxmlformats.org/presentationml/2006/main">
   <p:cSld>
     <p:spTree>
@@ -20415,7 +20308,7 @@
             <a:fld id="{2D6BF6D5-4A63-45E5-8F7F-88530ECEECFE}" type="slidenum">
               <a:rPr lang="en-US" smtClean="0"/>
               <a:pPr/>
-              <a:t>24</a:t>
+              <a:t>25</a:t>
             </a:fld>
             <a:endParaRPr lang="en-US"/>
           </a:p>
@@ -20434,7 +20327,7 @@
 </p:sld>
 </file>
 
-<file path=ppt/slides/slide25.xml><?xml version="1.0" encoding="utf-8"?>
+<file path=ppt/slides/slide26.xml><?xml version="1.0" encoding="utf-8"?>
 <p:sld xmlns:a="http://schemas.openxmlformats.org/drawingml/2006/main" xmlns:r="http://schemas.openxmlformats.org/officeDocument/2006/relationships" xmlns:p="http://schemas.openxmlformats.org/presentationml/2006/main">
   <p:cSld>
     <p:spTree>
@@ -20539,7 +20432,7 @@
             <a:fld id="{527FF320-592F-4310-BED6-ED57DA8E0B3F}" type="slidenum">
               <a:rPr lang="en-US" smtClean="0"/>
               <a:pPr/>
-              <a:t>25</a:t>
+              <a:t>26</a:t>
             </a:fld>
             <a:endParaRPr lang="en-US"/>
           </a:p>
@@ -20558,7 +20451,7 @@
 </p:sld>
 </file>
 
-<file path=ppt/slides/slide26.xml><?xml version="1.0" encoding="utf-8"?>
+<file path=ppt/slides/slide27.xml><?xml version="1.0" encoding="utf-8"?>
 <p:sld xmlns:a="http://schemas.openxmlformats.org/drawingml/2006/main" xmlns:r="http://schemas.openxmlformats.org/officeDocument/2006/relationships" xmlns:p="http://schemas.openxmlformats.org/presentationml/2006/main">
   <p:cSld>
     <p:spTree>
@@ -20689,7 +20582,7 @@
             <a:fld id="{94A61778-175D-474E-885D-81B1AC1A62AB}" type="slidenum">
               <a:rPr lang="en-US" smtClean="0"/>
               <a:pPr/>
-              <a:t>26</a:t>
+              <a:t>27</a:t>
             </a:fld>
             <a:endParaRPr lang="en-US"/>
           </a:p>
@@ -20951,7 +20844,7 @@
 </p:sld>
 </file>
 
-<file path=ppt/slides/slide27.xml><?xml version="1.0" encoding="utf-8"?>
+<file path=ppt/slides/slide28.xml><?xml version="1.0" encoding="utf-8"?>
 <p:sld xmlns:a="http://schemas.openxmlformats.org/drawingml/2006/main" xmlns:r="http://schemas.openxmlformats.org/officeDocument/2006/relationships" xmlns:p="http://schemas.openxmlformats.org/presentationml/2006/main">
   <p:cSld>
     <p:spTree>
@@ -21013,7 +20906,7 @@
 </p:sld>
 </file>
 
-<file path=ppt/slides/slide28.xml><?xml version="1.0" encoding="utf-8"?>
+<file path=ppt/slides/slide29.xml><?xml version="1.0" encoding="utf-8"?>
 <p:sld xmlns:a="http://schemas.openxmlformats.org/drawingml/2006/main" xmlns:r="http://schemas.openxmlformats.org/officeDocument/2006/relationships" xmlns:p="http://schemas.openxmlformats.org/presentationml/2006/main">
   <p:cSld>
     <p:spTree>
@@ -21067,69 +20960,6 @@
     <p:extLst>
       <p:ext uri="{BB962C8B-B14F-4D97-AF65-F5344CB8AC3E}">
         <p14:creationId xmlns:p14="http://schemas.microsoft.com/office/powerpoint/2010/main" val="2674272521"/>
-      </p:ext>
-    </p:extLst>
-  </p:cSld>
-  <p:clrMapOvr>
-    <a:masterClrMapping/>
-  </p:clrMapOvr>
-</p:sld>
-</file>
-
-<file path=ppt/slides/slide29.xml><?xml version="1.0" encoding="utf-8"?>
-<p:sld xmlns:a="http://schemas.openxmlformats.org/drawingml/2006/main" xmlns:r="http://schemas.openxmlformats.org/officeDocument/2006/relationships" xmlns:p="http://schemas.openxmlformats.org/presentationml/2006/main">
-  <p:cSld>
-    <p:spTree>
-      <p:nvGrpSpPr>
-        <p:cNvPr id="1" name=""/>
-        <p:cNvGrpSpPr/>
-        <p:nvPr/>
-      </p:nvGrpSpPr>
-      <p:grpSpPr>
-        <a:xfrm>
-          <a:off x="0" y="0"/>
-          <a:ext cx="0" cy="0"/>
-          <a:chOff x="0" y="0"/>
-          <a:chExt cx="0" cy="0"/>
-        </a:xfrm>
-      </p:grpSpPr>
-      <p:pic>
-        <p:nvPicPr>
-          <p:cNvPr id="5122" name="Picture 2"/>
-          <p:cNvPicPr>
-            <a:picLocks noChangeAspect="1" noChangeArrowheads="1"/>
-          </p:cNvPicPr>
-          <p:nvPr/>
-        </p:nvPicPr>
-        <p:blipFill>
-          <a:blip r:embed="rId2" cstate="print"/>
-          <a:srcRect/>
-          <a:stretch>
-            <a:fillRect/>
-          </a:stretch>
-        </p:blipFill>
-        <p:spPr bwMode="auto">
-          <a:xfrm>
-            <a:off x="815926" y="927598"/>
-            <a:ext cx="7519811" cy="5008968"/>
-          </a:xfrm>
-          <a:prstGeom prst="rect">
-            <a:avLst/>
-          </a:prstGeom>
-          <a:noFill/>
-          <a:ln w="9525">
-            <a:noFill/>
-            <a:miter lim="800000"/>
-            <a:headEnd/>
-            <a:tailEnd/>
-          </a:ln>
-          <a:effectLst/>
-        </p:spPr>
-      </p:pic>
-    </p:spTree>
-    <p:extLst>
-      <p:ext uri="{BB962C8B-B14F-4D97-AF65-F5344CB8AC3E}">
-        <p14:creationId xmlns:p14="http://schemas.microsoft.com/office/powerpoint/2010/main" val="3489346234"/>
       </p:ext>
     </p:extLst>
   </p:cSld>
@@ -22411,6 +22241,69 @@
           <a:chExt cx="0" cy="0"/>
         </a:xfrm>
       </p:grpSpPr>
+      <p:pic>
+        <p:nvPicPr>
+          <p:cNvPr id="5122" name="Picture 2"/>
+          <p:cNvPicPr>
+            <a:picLocks noChangeAspect="1" noChangeArrowheads="1"/>
+          </p:cNvPicPr>
+          <p:nvPr/>
+        </p:nvPicPr>
+        <p:blipFill>
+          <a:blip r:embed="rId2" cstate="print"/>
+          <a:srcRect/>
+          <a:stretch>
+            <a:fillRect/>
+          </a:stretch>
+        </p:blipFill>
+        <p:spPr bwMode="auto">
+          <a:xfrm>
+            <a:off x="815926" y="927598"/>
+            <a:ext cx="7519811" cy="5008968"/>
+          </a:xfrm>
+          <a:prstGeom prst="rect">
+            <a:avLst/>
+          </a:prstGeom>
+          <a:noFill/>
+          <a:ln w="9525">
+            <a:noFill/>
+            <a:miter lim="800000"/>
+            <a:headEnd/>
+            <a:tailEnd/>
+          </a:ln>
+          <a:effectLst/>
+        </p:spPr>
+      </p:pic>
+    </p:spTree>
+    <p:extLst>
+      <p:ext uri="{BB962C8B-B14F-4D97-AF65-F5344CB8AC3E}">
+        <p14:creationId xmlns:p14="http://schemas.microsoft.com/office/powerpoint/2010/main" val="3489346234"/>
+      </p:ext>
+    </p:extLst>
+  </p:cSld>
+  <p:clrMapOvr>
+    <a:masterClrMapping/>
+  </p:clrMapOvr>
+</p:sld>
+</file>
+
+<file path=ppt/slides/slide31.xml><?xml version="1.0" encoding="utf-8"?>
+<p:sld xmlns:a="http://schemas.openxmlformats.org/drawingml/2006/main" xmlns:r="http://schemas.openxmlformats.org/officeDocument/2006/relationships" xmlns:p="http://schemas.openxmlformats.org/presentationml/2006/main">
+  <p:cSld>
+    <p:spTree>
+      <p:nvGrpSpPr>
+        <p:cNvPr id="1" name=""/>
+        <p:cNvGrpSpPr/>
+        <p:nvPr/>
+      </p:nvGrpSpPr>
+      <p:grpSpPr>
+        <a:xfrm>
+          <a:off x="0" y="0"/>
+          <a:ext cx="0" cy="0"/>
+          <a:chOff x="0" y="0"/>
+          <a:chExt cx="0" cy="0"/>
+        </a:xfrm>
+      </p:grpSpPr>
       <p:sp>
         <p:nvSpPr>
           <p:cNvPr id="2" name="Title 1"/>
@@ -23613,7 +23506,7 @@
 </p:sld>
 </file>
 
-<file path=ppt/slides/slide31.xml><?xml version="1.0" encoding="utf-8"?>
+<file path=ppt/slides/slide32.xml><?xml version="1.0" encoding="utf-8"?>
 <p:sld xmlns:a="http://schemas.openxmlformats.org/drawingml/2006/main" xmlns:r="http://schemas.openxmlformats.org/officeDocument/2006/relationships" xmlns:p="http://schemas.openxmlformats.org/presentationml/2006/main">
   <p:cSld>
     <p:spTree>
@@ -26830,7 +26723,7 @@
 </p:sld>
 </file>
 
-<file path=ppt/slides/slide32.xml><?xml version="1.0" encoding="utf-8"?>
+<file path=ppt/slides/slide33.xml><?xml version="1.0" encoding="utf-8"?>
 <p:sld xmlns:a="http://schemas.openxmlformats.org/drawingml/2006/main" xmlns:r="http://schemas.openxmlformats.org/officeDocument/2006/relationships" xmlns:p="http://schemas.openxmlformats.org/presentationml/2006/main">
   <p:cSld>
     <p:spTree>
@@ -27007,7 +26900,7 @@
 </p:sld>
 </file>
 
-<file path=ppt/slides/slide33.xml><?xml version="1.0" encoding="utf-8"?>
+<file path=ppt/slides/slide34.xml><?xml version="1.0" encoding="utf-8"?>
 <p:sld xmlns:a="http://schemas.openxmlformats.org/drawingml/2006/main" xmlns:r="http://schemas.openxmlformats.org/officeDocument/2006/relationships" xmlns:p="http://schemas.openxmlformats.org/presentationml/2006/main">
   <p:cSld>
     <p:spTree>
@@ -27159,7 +27052,7 @@
 </p:sld>
 </file>
 
-<file path=ppt/slides/slide34.xml><?xml version="1.0" encoding="utf-8"?>
+<file path=ppt/slides/slide35.xml><?xml version="1.0" encoding="utf-8"?>
 <p:sld xmlns:a="http://schemas.openxmlformats.org/drawingml/2006/main" xmlns:r="http://schemas.openxmlformats.org/officeDocument/2006/relationships" xmlns:p="http://schemas.openxmlformats.org/presentationml/2006/main">
   <p:cSld>
     <p:spTree>
@@ -27242,7 +27135,7 @@
 </p:sld>
 </file>
 
-<file path=ppt/slides/slide35.xml><?xml version="1.0" encoding="utf-8"?>
+<file path=ppt/slides/slide36.xml><?xml version="1.0" encoding="utf-8"?>
 <p:sld xmlns:a="http://schemas.openxmlformats.org/drawingml/2006/main" xmlns:r="http://schemas.openxmlformats.org/officeDocument/2006/relationships" xmlns:p="http://schemas.openxmlformats.org/presentationml/2006/main">
   <p:cSld>
     <p:spTree>
@@ -27505,7 +27398,7 @@
 </p:sld>
 </file>
 
-<file path=ppt/slides/slide36.xml><?xml version="1.0" encoding="utf-8"?>
+<file path=ppt/slides/slide37.xml><?xml version="1.0" encoding="utf-8"?>
 <p:sld xmlns:a="http://schemas.openxmlformats.org/drawingml/2006/main" xmlns:r="http://schemas.openxmlformats.org/officeDocument/2006/relationships" xmlns:p="http://schemas.openxmlformats.org/presentationml/2006/main">
   <p:cSld>
     <p:spTree>
@@ -28988,7 +28881,7 @@
 </p:sld>
 </file>
 
-<file path=ppt/slides/slide37.xml><?xml version="1.0" encoding="utf-8"?>
+<file path=ppt/slides/slide38.xml><?xml version="1.0" encoding="utf-8"?>
 <p:sld xmlns:a="http://schemas.openxmlformats.org/drawingml/2006/main" xmlns:r="http://schemas.openxmlformats.org/officeDocument/2006/relationships" xmlns:p="http://schemas.openxmlformats.org/presentationml/2006/main">
   <p:cSld>
     <p:spTree>
@@ -29050,7 +28943,7 @@
 </p:sld>
 </file>
 
-<file path=ppt/slides/slide38.xml><?xml version="1.0" encoding="utf-8"?>
+<file path=ppt/slides/slide39.xml><?xml version="1.0" encoding="utf-8"?>
 <p:sld xmlns:a="http://schemas.openxmlformats.org/drawingml/2006/main" xmlns:r="http://schemas.openxmlformats.org/officeDocument/2006/relationships" xmlns:p="http://schemas.openxmlformats.org/presentationml/2006/main">
   <p:cSld>
     <p:spTree>
@@ -29112,7 +29005,620 @@
 </p:sld>
 </file>
 
-<file path=ppt/slides/slide39.xml><?xml version="1.0" encoding="utf-8"?>
+<file path=ppt/slides/slide4.xml><?xml version="1.0" encoding="utf-8"?>
+<p:sld xmlns:a="http://schemas.openxmlformats.org/drawingml/2006/main" xmlns:r="http://schemas.openxmlformats.org/officeDocument/2006/relationships" xmlns:p="http://schemas.openxmlformats.org/presentationml/2006/main">
+  <p:cSld>
+    <p:spTree>
+      <p:nvGrpSpPr>
+        <p:cNvPr id="1" name=""/>
+        <p:cNvGrpSpPr/>
+        <p:nvPr/>
+      </p:nvGrpSpPr>
+      <p:grpSpPr>
+        <a:xfrm>
+          <a:off x="0" y="0"/>
+          <a:ext cx="0" cy="0"/>
+          <a:chOff x="0" y="0"/>
+          <a:chExt cx="0" cy="0"/>
+        </a:xfrm>
+      </p:grpSpPr>
+      <p:sp>
+        <p:nvSpPr>
+          <p:cNvPr id="19458" name="Slide Number Placeholder 5"/>
+          <p:cNvSpPr>
+            <a:spLocks noGrp="1"/>
+          </p:cNvSpPr>
+          <p:nvPr>
+            <p:ph type="sldNum" sz="quarter" idx="12"/>
+          </p:nvPr>
+        </p:nvSpPr>
+        <p:spPr>
+          <a:noFill/>
+          <a:ln/>
+          <a:extLst>
+            <a:ext uri="{909E8E84-426E-40DD-AFC4-6F175D3DCCD1}">
+              <a14:hiddenFill xmlns:a14="http://schemas.microsoft.com/office/drawing/2010/main">
+                <a:solidFill>
+                  <a:srgbClr val="FFFFFF"/>
+                </a:solidFill>
+              </a14:hiddenFill>
+            </a:ext>
+            <a:ext uri="{91240B29-F687-4F45-9708-019B960494DF}">
+              <a14:hiddenLine xmlns:a14="http://schemas.microsoft.com/office/drawing/2010/main" w="9525">
+                <a:solidFill>
+                  <a:srgbClr val="000000"/>
+                </a:solidFill>
+                <a:miter lim="800000"/>
+                <a:headEnd/>
+                <a:tailEnd/>
+              </a14:hiddenLine>
+            </a:ext>
+          </a:extLst>
+        </p:spPr>
+        <p:txBody>
+          <a:bodyPr/>
+          <a:lstStyle>
+            <a:lvl1pPr eaLnBrk="0" hangingPunct="0">
+              <a:defRPr>
+                <a:solidFill>
+                  <a:schemeClr val="tx1"/>
+                </a:solidFill>
+                <a:latin typeface="Arial" charset="0"/>
+              </a:defRPr>
+            </a:lvl1pPr>
+            <a:lvl2pPr marL="557213" indent="-214313" eaLnBrk="0" hangingPunct="0">
+              <a:defRPr>
+                <a:solidFill>
+                  <a:schemeClr val="tx1"/>
+                </a:solidFill>
+                <a:latin typeface="Arial" charset="0"/>
+              </a:defRPr>
+            </a:lvl2pPr>
+            <a:lvl3pPr marL="857250" indent="-171450" eaLnBrk="0" hangingPunct="0">
+              <a:defRPr>
+                <a:solidFill>
+                  <a:schemeClr val="tx1"/>
+                </a:solidFill>
+                <a:latin typeface="Arial" charset="0"/>
+              </a:defRPr>
+            </a:lvl3pPr>
+            <a:lvl4pPr marL="1200150" indent="-171450" eaLnBrk="0" hangingPunct="0">
+              <a:defRPr>
+                <a:solidFill>
+                  <a:schemeClr val="tx1"/>
+                </a:solidFill>
+                <a:latin typeface="Arial" charset="0"/>
+              </a:defRPr>
+            </a:lvl4pPr>
+            <a:lvl5pPr marL="1543050" indent="-171450" eaLnBrk="0" hangingPunct="0">
+              <a:defRPr>
+                <a:solidFill>
+                  <a:schemeClr val="tx1"/>
+                </a:solidFill>
+                <a:latin typeface="Arial" charset="0"/>
+              </a:defRPr>
+            </a:lvl5pPr>
+            <a:lvl6pPr marL="1885950" indent="-171450" eaLnBrk="0" fontAlgn="base" hangingPunct="0">
+              <a:spcBef>
+                <a:spcPct val="0"/>
+              </a:spcBef>
+              <a:spcAft>
+                <a:spcPct val="0"/>
+              </a:spcAft>
+              <a:defRPr>
+                <a:solidFill>
+                  <a:schemeClr val="tx1"/>
+                </a:solidFill>
+                <a:latin typeface="Arial" charset="0"/>
+              </a:defRPr>
+            </a:lvl6pPr>
+            <a:lvl7pPr marL="2228850" indent="-171450" eaLnBrk="0" fontAlgn="base" hangingPunct="0">
+              <a:spcBef>
+                <a:spcPct val="0"/>
+              </a:spcBef>
+              <a:spcAft>
+                <a:spcPct val="0"/>
+              </a:spcAft>
+              <a:defRPr>
+                <a:solidFill>
+                  <a:schemeClr val="tx1"/>
+                </a:solidFill>
+                <a:latin typeface="Arial" charset="0"/>
+              </a:defRPr>
+            </a:lvl7pPr>
+            <a:lvl8pPr marL="2571750" indent="-171450" eaLnBrk="0" fontAlgn="base" hangingPunct="0">
+              <a:spcBef>
+                <a:spcPct val="0"/>
+              </a:spcBef>
+              <a:spcAft>
+                <a:spcPct val="0"/>
+              </a:spcAft>
+              <a:defRPr>
+                <a:solidFill>
+                  <a:schemeClr val="tx1"/>
+                </a:solidFill>
+                <a:latin typeface="Arial" charset="0"/>
+              </a:defRPr>
+            </a:lvl8pPr>
+            <a:lvl9pPr marL="2914650" indent="-171450" eaLnBrk="0" fontAlgn="base" hangingPunct="0">
+              <a:spcBef>
+                <a:spcPct val="0"/>
+              </a:spcBef>
+              <a:spcAft>
+                <a:spcPct val="0"/>
+              </a:spcAft>
+              <a:defRPr>
+                <a:solidFill>
+                  <a:schemeClr val="tx1"/>
+                </a:solidFill>
+                <a:latin typeface="Arial" charset="0"/>
+              </a:defRPr>
+            </a:lvl9pPr>
+          </a:lstStyle>
+          <a:p>
+            <a:pPr eaLnBrk="1" hangingPunct="1"/>
+            <a:fld id="{5DE43916-2E53-4087-A7F0-C9C9128B3A17}" type="slidenum">
+              <a:rPr lang="en-US" smtClean="0"/>
+              <a:pPr eaLnBrk="1" hangingPunct="1"/>
+              <a:t>4</a:t>
+            </a:fld>
+            <a:endParaRPr lang="en-US"/>
+          </a:p>
+        </p:txBody>
+      </p:sp>
+      <p:sp>
+        <p:nvSpPr>
+          <p:cNvPr id="19459" name="Rectangle 2"/>
+          <p:cNvSpPr>
+            <a:spLocks noGrp="1" noChangeArrowheads="1"/>
+          </p:cNvSpPr>
+          <p:nvPr>
+            <p:ph type="title"/>
+          </p:nvPr>
+        </p:nvSpPr>
+        <p:spPr/>
+        <p:txBody>
+          <a:bodyPr/>
+          <a:lstStyle/>
+          <a:p>
+            <a:pPr eaLnBrk="1" hangingPunct="1"/>
+            <a:r>
+              <a:rPr lang="en-US"/>
+              <a:t>Driving Force</a:t>
+            </a:r>
+          </a:p>
+        </p:txBody>
+      </p:sp>
+      <p:sp>
+        <p:nvSpPr>
+          <p:cNvPr id="19460" name="Rectangle 3"/>
+          <p:cNvSpPr>
+            <a:spLocks noGrp="1" noChangeArrowheads="1"/>
+          </p:cNvSpPr>
+          <p:nvPr>
+            <p:ph type="body" idx="1"/>
+          </p:nvPr>
+        </p:nvSpPr>
+        <p:spPr/>
+        <p:txBody>
+          <a:bodyPr>
+            <a:normAutofit/>
+          </a:bodyPr>
+          <a:lstStyle/>
+          <a:p>
+            <a:pPr eaLnBrk="1" hangingPunct="1"/>
+            <a:r>
+              <a:rPr lang="en-US" sz="1800" dirty="0"/>
+              <a:t>Last section we added a force                   that killed our oscillation</a:t>
+            </a:r>
+          </a:p>
+          <a:p>
+            <a:pPr eaLnBrk="1" hangingPunct="1"/>
+            <a:endParaRPr lang="en-US" sz="1800" dirty="0"/>
+          </a:p>
+          <a:p>
+            <a:pPr eaLnBrk="1" hangingPunct="1"/>
+            <a:r>
+              <a:rPr lang="en-US" sz="1800" dirty="0"/>
+              <a:t>Suppose we want to keep it going</a:t>
+            </a:r>
+          </a:p>
+          <a:p>
+            <a:pPr eaLnBrk="1" hangingPunct="1"/>
+            <a:endParaRPr lang="en-US" sz="1800" dirty="0"/>
+          </a:p>
+          <a:p>
+            <a:pPr eaLnBrk="1" hangingPunct="1"/>
+            <a:r>
+              <a:rPr lang="en-US" sz="1800" dirty="0"/>
+              <a:t>Add a force </a:t>
+            </a:r>
+          </a:p>
+          <a:p>
+            <a:pPr eaLnBrk="1" hangingPunct="1"/>
+            <a:endParaRPr lang="en-US" sz="1800" dirty="0"/>
+          </a:p>
+          <a:p>
+            <a:pPr eaLnBrk="1" hangingPunct="1">
+              <a:buFontTx/>
+              <a:buNone/>
+            </a:pPr>
+            <a:r>
+              <a:rPr lang="en-US" sz="1800" dirty="0"/>
+              <a:t>     where F</a:t>
+            </a:r>
+            <a:r>
+              <a:rPr lang="en-US" sz="1800" baseline="-25000" dirty="0"/>
+              <a:t>o</a:t>
+            </a:r>
+            <a:r>
+              <a:rPr lang="en-US" sz="1800" dirty="0"/>
+              <a:t> is a constant and where </a:t>
+            </a:r>
+            <a:r>
+              <a:rPr lang="en-US" sz="1800" dirty="0">
+                <a:sym typeface="Symbol" pitchFamily="18" charset="2"/>
+              </a:rPr>
+              <a:t></a:t>
+            </a:r>
+            <a:r>
+              <a:rPr lang="en-US" sz="1800" baseline="-25000" dirty="0"/>
+              <a:t>f</a:t>
+            </a:r>
+            <a:r>
+              <a:rPr lang="en-US" sz="1800" dirty="0"/>
+              <a:t> is the angular frequency of the driving force</a:t>
+            </a:r>
+          </a:p>
+          <a:p>
+            <a:pPr eaLnBrk="1" hangingPunct="1">
+              <a:buFontTx/>
+              <a:buNone/>
+            </a:pPr>
+            <a:endParaRPr lang="en-US" sz="1800" dirty="0"/>
+          </a:p>
+          <a:p>
+            <a:pPr eaLnBrk="1" hangingPunct="1">
+              <a:buFontTx/>
+              <a:buNone/>
+            </a:pPr>
+            <a:endParaRPr lang="en-US" sz="1800" dirty="0"/>
+          </a:p>
+          <a:p>
+            <a:pPr eaLnBrk="1" hangingPunct="1">
+              <a:buFontTx/>
+              <a:buNone/>
+            </a:pPr>
+            <a:endParaRPr lang="en-US" sz="1800" dirty="0"/>
+          </a:p>
+          <a:p>
+            <a:pPr eaLnBrk="1" hangingPunct="1"/>
+            <a:r>
+              <a:rPr lang="en-US" sz="1800" dirty="0"/>
+              <a:t>This one is very hard to solve</a:t>
+            </a:r>
+          </a:p>
+        </p:txBody>
+      </p:sp>
+      <p:sp>
+        <p:nvSpPr>
+          <p:cNvPr id="19461" name="Rectangle 4"/>
+          <p:cNvSpPr>
+            <a:spLocks noChangeArrowheads="1"/>
+          </p:cNvSpPr>
+          <p:nvPr/>
+        </p:nvSpPr>
+        <p:spPr bwMode="auto">
+          <a:xfrm>
+            <a:off x="1143001" y="707209"/>
+            <a:ext cx="184731" cy="300082"/>
+          </a:xfrm>
+          <a:prstGeom prst="rect">
+            <a:avLst/>
+          </a:prstGeom>
+          <a:noFill/>
+          <a:ln>
+            <a:noFill/>
+          </a:ln>
+          <a:extLst>
+            <a:ext uri="{909E8E84-426E-40DD-AFC4-6F175D3DCCD1}">
+              <a14:hiddenFill xmlns:a14="http://schemas.microsoft.com/office/drawing/2010/main">
+                <a:solidFill>
+                  <a:srgbClr val="FFFFFF"/>
+                </a:solidFill>
+              </a14:hiddenFill>
+            </a:ext>
+            <a:ext uri="{91240B29-F687-4F45-9708-019B960494DF}">
+              <a14:hiddenLine xmlns:a14="http://schemas.microsoft.com/office/drawing/2010/main" w="9525" algn="ctr">
+                <a:solidFill>
+                  <a:srgbClr val="000000"/>
+                </a:solidFill>
+                <a:miter lim="800000"/>
+                <a:headEnd/>
+                <a:tailEnd/>
+              </a14:hiddenLine>
+            </a:ext>
+          </a:extLst>
+        </p:spPr>
+        <p:txBody>
+          <a:bodyPr wrap="none" anchor="ctr">
+            <a:spAutoFit/>
+          </a:bodyPr>
+          <a:lstStyle/>
+          <a:p>
+            <a:endParaRPr lang="en-US" sz="1350"/>
+          </a:p>
+        </p:txBody>
+      </p:sp>
+      <p:graphicFrame>
+        <p:nvGraphicFramePr>
+          <p:cNvPr id="19462" name="Object 5"/>
+          <p:cNvGraphicFramePr>
+            <a:graphicFrameLocks noChangeAspect="1"/>
+          </p:cNvGraphicFramePr>
+          <p:nvPr>
+            <p:extLst>
+              <p:ext uri="{D42A27DB-BD31-4B8C-83A1-F6EECF244321}">
+                <p14:modId xmlns:p14="http://schemas.microsoft.com/office/powerpoint/2010/main" val="3118549179"/>
+              </p:ext>
+            </p:extLst>
+          </p:nvPr>
+        </p:nvGraphicFramePr>
+        <p:xfrm>
+          <a:off x="3731481" y="1669537"/>
+          <a:ext cx="757170" cy="292098"/>
+        </p:xfrm>
+        <a:graphic>
+          <a:graphicData uri="http://schemas.openxmlformats.org/presentationml/2006/ole">
+            <mc:AlternateContent xmlns:mc="http://schemas.openxmlformats.org/markup-compatibility/2006">
+              <mc:Choice xmlns:v="urn:schemas-microsoft-com:vml" Requires="v">
+                <p:oleObj name="Equation" r:id="rId2" imgW="596900" imgH="228600" progId="Equation.3">
+                  <p:embed/>
+                </p:oleObj>
+              </mc:Choice>
+              <mc:Fallback>
+                <p:oleObj name="Equation" r:id="rId2" imgW="596900" imgH="228600" progId="Equation.3">
+                  <p:embed/>
+                  <p:pic>
+                    <p:nvPicPr>
+                      <p:cNvPr id="19462" name="Object 5"/>
+                      <p:cNvPicPr>
+                        <a:picLocks noChangeAspect="1" noChangeArrowheads="1"/>
+                      </p:cNvPicPr>
+                      <p:nvPr/>
+                    </p:nvPicPr>
+                    <p:blipFill>
+                      <a:blip r:embed="rId3">
+                        <a:extLst>
+                          <a:ext uri="{28A0092B-C50C-407E-A947-70E740481C1C}">
+                            <a14:useLocalDpi xmlns:a14="http://schemas.microsoft.com/office/drawing/2010/main" val="0"/>
+                          </a:ext>
+                        </a:extLst>
+                      </a:blip>
+                      <a:srcRect/>
+                      <a:stretch>
+                        <a:fillRect/>
+                      </a:stretch>
+                    </p:blipFill>
+                    <p:spPr bwMode="auto">
+                      <a:xfrm>
+                        <a:off x="3731481" y="1669537"/>
+                        <a:ext cx="757170" cy="292098"/>
+                      </a:xfrm>
+                      <a:prstGeom prst="rect">
+                        <a:avLst/>
+                      </a:prstGeom>
+                      <a:noFill/>
+                      <a:ln>
+                        <a:noFill/>
+                      </a:ln>
+                    </p:spPr>
+                  </p:pic>
+                </p:oleObj>
+              </mc:Fallback>
+            </mc:AlternateContent>
+          </a:graphicData>
+        </a:graphic>
+      </p:graphicFrame>
+      <p:sp>
+        <p:nvSpPr>
+          <p:cNvPr id="19463" name="Rectangle 6"/>
+          <p:cNvSpPr>
+            <a:spLocks noChangeArrowheads="1"/>
+          </p:cNvSpPr>
+          <p:nvPr/>
+        </p:nvSpPr>
+        <p:spPr bwMode="auto">
+          <a:xfrm>
+            <a:off x="1143001" y="707209"/>
+            <a:ext cx="184731" cy="300082"/>
+          </a:xfrm>
+          <a:prstGeom prst="rect">
+            <a:avLst/>
+          </a:prstGeom>
+          <a:noFill/>
+          <a:ln>
+            <a:noFill/>
+          </a:ln>
+          <a:extLst>
+            <a:ext uri="{909E8E84-426E-40DD-AFC4-6F175D3DCCD1}">
+              <a14:hiddenFill xmlns:a14="http://schemas.microsoft.com/office/drawing/2010/main">
+                <a:solidFill>
+                  <a:srgbClr val="FFFFFF"/>
+                </a:solidFill>
+              </a14:hiddenFill>
+            </a:ext>
+            <a:ext uri="{91240B29-F687-4F45-9708-019B960494DF}">
+              <a14:hiddenLine xmlns:a14="http://schemas.microsoft.com/office/drawing/2010/main" w="9525" algn="ctr">
+                <a:solidFill>
+                  <a:srgbClr val="000000"/>
+                </a:solidFill>
+                <a:miter lim="800000"/>
+                <a:headEnd/>
+                <a:tailEnd/>
+              </a14:hiddenLine>
+            </a:ext>
+          </a:extLst>
+        </p:spPr>
+        <p:txBody>
+          <a:bodyPr wrap="none" anchor="ctr">
+            <a:spAutoFit/>
+          </a:bodyPr>
+          <a:lstStyle/>
+          <a:p>
+            <a:endParaRPr lang="en-US" sz="1350"/>
+          </a:p>
+        </p:txBody>
+      </p:sp>
+      <p:graphicFrame>
+        <p:nvGraphicFramePr>
+          <p:cNvPr id="19464" name="Object 7"/>
+          <p:cNvGraphicFramePr>
+            <a:graphicFrameLocks noChangeAspect="1"/>
+          </p:cNvGraphicFramePr>
+          <p:nvPr>
+            <p:extLst>
+              <p:ext uri="{D42A27DB-BD31-4B8C-83A1-F6EECF244321}">
+                <p14:modId xmlns:p14="http://schemas.microsoft.com/office/powerpoint/2010/main" val="1315654589"/>
+              </p:ext>
+            </p:extLst>
+          </p:nvPr>
+        </p:nvGraphicFramePr>
+        <p:xfrm>
+          <a:off x="2109932" y="2860706"/>
+          <a:ext cx="1990990" cy="436308"/>
+        </p:xfrm>
+        <a:graphic>
+          <a:graphicData uri="http://schemas.openxmlformats.org/presentationml/2006/ole">
+            <mc:AlternateContent xmlns:mc="http://schemas.openxmlformats.org/markup-compatibility/2006">
+              <mc:Choice xmlns:v="urn:schemas-microsoft-com:vml" Requires="v">
+                <p:oleObj name="Equation" r:id="rId4" imgW="1104900" imgH="241300" progId="Equation.3">
+                  <p:embed/>
+                </p:oleObj>
+              </mc:Choice>
+              <mc:Fallback>
+                <p:oleObj name="Equation" r:id="rId4" imgW="1104900" imgH="241300" progId="Equation.3">
+                  <p:embed/>
+                  <p:pic>
+                    <p:nvPicPr>
+                      <p:cNvPr id="19464" name="Object 7"/>
+                      <p:cNvPicPr>
+                        <a:picLocks noChangeAspect="1" noChangeArrowheads="1"/>
+                      </p:cNvPicPr>
+                      <p:nvPr/>
+                    </p:nvPicPr>
+                    <p:blipFill>
+                      <a:blip r:embed="rId5">
+                        <a:extLst>
+                          <a:ext uri="{28A0092B-C50C-407E-A947-70E740481C1C}">
+                            <a14:useLocalDpi xmlns:a14="http://schemas.microsoft.com/office/drawing/2010/main" val="0"/>
+                          </a:ext>
+                        </a:extLst>
+                      </a:blip>
+                      <a:srcRect/>
+                      <a:stretch>
+                        <a:fillRect/>
+                      </a:stretch>
+                    </p:blipFill>
+                    <p:spPr bwMode="auto">
+                      <a:xfrm>
+                        <a:off x="2109932" y="2860706"/>
+                        <a:ext cx="1990990" cy="436308"/>
+                      </a:xfrm>
+                      <a:prstGeom prst="rect">
+                        <a:avLst/>
+                      </a:prstGeom>
+                      <a:noFill/>
+                      <a:ln>
+                        <a:noFill/>
+                      </a:ln>
+                    </p:spPr>
+                  </p:pic>
+                </p:oleObj>
+              </mc:Fallback>
+            </mc:AlternateContent>
+          </a:graphicData>
+        </a:graphic>
+      </p:graphicFrame>
+      <p:graphicFrame>
+        <p:nvGraphicFramePr>
+          <p:cNvPr id="19465" name="Object 8"/>
+          <p:cNvGraphicFramePr>
+            <a:graphicFrameLocks noChangeAspect="1"/>
+          </p:cNvGraphicFramePr>
+          <p:nvPr>
+            <p:extLst>
+              <p:ext uri="{D42A27DB-BD31-4B8C-83A1-F6EECF244321}">
+                <p14:modId xmlns:p14="http://schemas.microsoft.com/office/powerpoint/2010/main" val="1468611588"/>
+              </p:ext>
+            </p:extLst>
+          </p:nvPr>
+        </p:nvGraphicFramePr>
+        <p:xfrm>
+          <a:off x="2482883" y="4275280"/>
+          <a:ext cx="3585914" cy="436309"/>
+        </p:xfrm>
+        <a:graphic>
+          <a:graphicData uri="http://schemas.openxmlformats.org/presentationml/2006/ole">
+            <mc:AlternateContent xmlns:mc="http://schemas.openxmlformats.org/markup-compatibility/2006">
+              <mc:Choice xmlns:v="urn:schemas-microsoft-com:vml" Requires="v">
+                <p:oleObj name="Equation" r:id="rId6" imgW="1993900" imgH="241300" progId="Equation.3">
+                  <p:embed/>
+                </p:oleObj>
+              </mc:Choice>
+              <mc:Fallback>
+                <p:oleObj name="Equation" r:id="rId6" imgW="1993900" imgH="241300" progId="Equation.3">
+                  <p:embed/>
+                  <p:pic>
+                    <p:nvPicPr>
+                      <p:cNvPr id="19465" name="Object 8"/>
+                      <p:cNvPicPr>
+                        <a:picLocks noChangeAspect="1" noChangeArrowheads="1"/>
+                      </p:cNvPicPr>
+                      <p:nvPr/>
+                    </p:nvPicPr>
+                    <p:blipFill>
+                      <a:blip r:embed="rId7">
+                        <a:extLst>
+                          <a:ext uri="{28A0092B-C50C-407E-A947-70E740481C1C}">
+                            <a14:useLocalDpi xmlns:a14="http://schemas.microsoft.com/office/drawing/2010/main" val="0"/>
+                          </a:ext>
+                        </a:extLst>
+                      </a:blip>
+                      <a:srcRect/>
+                      <a:stretch>
+                        <a:fillRect/>
+                      </a:stretch>
+                    </p:blipFill>
+                    <p:spPr bwMode="auto">
+                      <a:xfrm>
+                        <a:off x="2482883" y="4275280"/>
+                        <a:ext cx="3585914" cy="436309"/>
+                      </a:xfrm>
+                      <a:prstGeom prst="rect">
+                        <a:avLst/>
+                      </a:prstGeom>
+                      <a:noFill/>
+                      <a:ln>
+                        <a:noFill/>
+                      </a:ln>
+                    </p:spPr>
+                  </p:pic>
+                </p:oleObj>
+              </mc:Fallback>
+            </mc:AlternateContent>
+          </a:graphicData>
+        </a:graphic>
+      </p:graphicFrame>
+    </p:spTree>
+  </p:cSld>
+  <p:clrMapOvr>
+    <a:masterClrMapping/>
+  </p:clrMapOvr>
+</p:sld>
+</file>
+
+<file path=ppt/slides/slide40.xml><?xml version="1.0" encoding="utf-8"?>
 <p:sld xmlns:a="http://schemas.openxmlformats.org/drawingml/2006/main" xmlns:r="http://schemas.openxmlformats.org/officeDocument/2006/relationships" xmlns:p="http://schemas.openxmlformats.org/presentationml/2006/main">
   <p:cSld>
     <p:spTree>
@@ -29497,620 +30003,7 @@
 </p:sld>
 </file>
 
-<file path=ppt/slides/slide4.xml><?xml version="1.0" encoding="utf-8"?>
-<p:sld xmlns:a="http://schemas.openxmlformats.org/drawingml/2006/main" xmlns:r="http://schemas.openxmlformats.org/officeDocument/2006/relationships" xmlns:p="http://schemas.openxmlformats.org/presentationml/2006/main">
-  <p:cSld>
-    <p:spTree>
-      <p:nvGrpSpPr>
-        <p:cNvPr id="1" name=""/>
-        <p:cNvGrpSpPr/>
-        <p:nvPr/>
-      </p:nvGrpSpPr>
-      <p:grpSpPr>
-        <a:xfrm>
-          <a:off x="0" y="0"/>
-          <a:ext cx="0" cy="0"/>
-          <a:chOff x="0" y="0"/>
-          <a:chExt cx="0" cy="0"/>
-        </a:xfrm>
-      </p:grpSpPr>
-      <p:sp>
-        <p:nvSpPr>
-          <p:cNvPr id="19458" name="Slide Number Placeholder 5"/>
-          <p:cNvSpPr>
-            <a:spLocks noGrp="1"/>
-          </p:cNvSpPr>
-          <p:nvPr>
-            <p:ph type="sldNum" sz="quarter" idx="12"/>
-          </p:nvPr>
-        </p:nvSpPr>
-        <p:spPr>
-          <a:noFill/>
-          <a:ln/>
-          <a:extLst>
-            <a:ext uri="{909E8E84-426E-40DD-AFC4-6F175D3DCCD1}">
-              <a14:hiddenFill xmlns:a14="http://schemas.microsoft.com/office/drawing/2010/main">
-                <a:solidFill>
-                  <a:srgbClr val="FFFFFF"/>
-                </a:solidFill>
-              </a14:hiddenFill>
-            </a:ext>
-            <a:ext uri="{91240B29-F687-4F45-9708-019B960494DF}">
-              <a14:hiddenLine xmlns:a14="http://schemas.microsoft.com/office/drawing/2010/main" w="9525">
-                <a:solidFill>
-                  <a:srgbClr val="000000"/>
-                </a:solidFill>
-                <a:miter lim="800000"/>
-                <a:headEnd/>
-                <a:tailEnd/>
-              </a14:hiddenLine>
-            </a:ext>
-          </a:extLst>
-        </p:spPr>
-        <p:txBody>
-          <a:bodyPr/>
-          <a:lstStyle>
-            <a:lvl1pPr eaLnBrk="0" hangingPunct="0">
-              <a:defRPr>
-                <a:solidFill>
-                  <a:schemeClr val="tx1"/>
-                </a:solidFill>
-                <a:latin typeface="Arial" charset="0"/>
-              </a:defRPr>
-            </a:lvl1pPr>
-            <a:lvl2pPr marL="557213" indent="-214313" eaLnBrk="0" hangingPunct="0">
-              <a:defRPr>
-                <a:solidFill>
-                  <a:schemeClr val="tx1"/>
-                </a:solidFill>
-                <a:latin typeface="Arial" charset="0"/>
-              </a:defRPr>
-            </a:lvl2pPr>
-            <a:lvl3pPr marL="857250" indent="-171450" eaLnBrk="0" hangingPunct="0">
-              <a:defRPr>
-                <a:solidFill>
-                  <a:schemeClr val="tx1"/>
-                </a:solidFill>
-                <a:latin typeface="Arial" charset="0"/>
-              </a:defRPr>
-            </a:lvl3pPr>
-            <a:lvl4pPr marL="1200150" indent="-171450" eaLnBrk="0" hangingPunct="0">
-              <a:defRPr>
-                <a:solidFill>
-                  <a:schemeClr val="tx1"/>
-                </a:solidFill>
-                <a:latin typeface="Arial" charset="0"/>
-              </a:defRPr>
-            </a:lvl4pPr>
-            <a:lvl5pPr marL="1543050" indent="-171450" eaLnBrk="0" hangingPunct="0">
-              <a:defRPr>
-                <a:solidFill>
-                  <a:schemeClr val="tx1"/>
-                </a:solidFill>
-                <a:latin typeface="Arial" charset="0"/>
-              </a:defRPr>
-            </a:lvl5pPr>
-            <a:lvl6pPr marL="1885950" indent="-171450" eaLnBrk="0" fontAlgn="base" hangingPunct="0">
-              <a:spcBef>
-                <a:spcPct val="0"/>
-              </a:spcBef>
-              <a:spcAft>
-                <a:spcPct val="0"/>
-              </a:spcAft>
-              <a:defRPr>
-                <a:solidFill>
-                  <a:schemeClr val="tx1"/>
-                </a:solidFill>
-                <a:latin typeface="Arial" charset="0"/>
-              </a:defRPr>
-            </a:lvl6pPr>
-            <a:lvl7pPr marL="2228850" indent="-171450" eaLnBrk="0" fontAlgn="base" hangingPunct="0">
-              <a:spcBef>
-                <a:spcPct val="0"/>
-              </a:spcBef>
-              <a:spcAft>
-                <a:spcPct val="0"/>
-              </a:spcAft>
-              <a:defRPr>
-                <a:solidFill>
-                  <a:schemeClr val="tx1"/>
-                </a:solidFill>
-                <a:latin typeface="Arial" charset="0"/>
-              </a:defRPr>
-            </a:lvl7pPr>
-            <a:lvl8pPr marL="2571750" indent="-171450" eaLnBrk="0" fontAlgn="base" hangingPunct="0">
-              <a:spcBef>
-                <a:spcPct val="0"/>
-              </a:spcBef>
-              <a:spcAft>
-                <a:spcPct val="0"/>
-              </a:spcAft>
-              <a:defRPr>
-                <a:solidFill>
-                  <a:schemeClr val="tx1"/>
-                </a:solidFill>
-                <a:latin typeface="Arial" charset="0"/>
-              </a:defRPr>
-            </a:lvl8pPr>
-            <a:lvl9pPr marL="2914650" indent="-171450" eaLnBrk="0" fontAlgn="base" hangingPunct="0">
-              <a:spcBef>
-                <a:spcPct val="0"/>
-              </a:spcBef>
-              <a:spcAft>
-                <a:spcPct val="0"/>
-              </a:spcAft>
-              <a:defRPr>
-                <a:solidFill>
-                  <a:schemeClr val="tx1"/>
-                </a:solidFill>
-                <a:latin typeface="Arial" charset="0"/>
-              </a:defRPr>
-            </a:lvl9pPr>
-          </a:lstStyle>
-          <a:p>
-            <a:pPr eaLnBrk="1" hangingPunct="1"/>
-            <a:fld id="{5DE43916-2E53-4087-A7F0-C9C9128B3A17}" type="slidenum">
-              <a:rPr lang="en-US" smtClean="0"/>
-              <a:pPr eaLnBrk="1" hangingPunct="1"/>
-              <a:t>4</a:t>
-            </a:fld>
-            <a:endParaRPr lang="en-US"/>
-          </a:p>
-        </p:txBody>
-      </p:sp>
-      <p:sp>
-        <p:nvSpPr>
-          <p:cNvPr id="19459" name="Rectangle 2"/>
-          <p:cNvSpPr>
-            <a:spLocks noGrp="1" noChangeArrowheads="1"/>
-          </p:cNvSpPr>
-          <p:nvPr>
-            <p:ph type="title"/>
-          </p:nvPr>
-        </p:nvSpPr>
-        <p:spPr/>
-        <p:txBody>
-          <a:bodyPr/>
-          <a:lstStyle/>
-          <a:p>
-            <a:pPr eaLnBrk="1" hangingPunct="1"/>
-            <a:r>
-              <a:rPr lang="en-US"/>
-              <a:t>Driving Force</a:t>
-            </a:r>
-          </a:p>
-        </p:txBody>
-      </p:sp>
-      <p:sp>
-        <p:nvSpPr>
-          <p:cNvPr id="19460" name="Rectangle 3"/>
-          <p:cNvSpPr>
-            <a:spLocks noGrp="1" noChangeArrowheads="1"/>
-          </p:cNvSpPr>
-          <p:nvPr>
-            <p:ph type="body" idx="1"/>
-          </p:nvPr>
-        </p:nvSpPr>
-        <p:spPr/>
-        <p:txBody>
-          <a:bodyPr>
-            <a:normAutofit/>
-          </a:bodyPr>
-          <a:lstStyle/>
-          <a:p>
-            <a:pPr eaLnBrk="1" hangingPunct="1"/>
-            <a:r>
-              <a:rPr lang="en-US" sz="1800" dirty="0"/>
-              <a:t>Last section we added a force                   that killed our oscillation</a:t>
-            </a:r>
-          </a:p>
-          <a:p>
-            <a:pPr eaLnBrk="1" hangingPunct="1"/>
-            <a:endParaRPr lang="en-US" sz="1800" dirty="0"/>
-          </a:p>
-          <a:p>
-            <a:pPr eaLnBrk="1" hangingPunct="1"/>
-            <a:r>
-              <a:rPr lang="en-US" sz="1800" dirty="0"/>
-              <a:t>Suppose we want to keep it going</a:t>
-            </a:r>
-          </a:p>
-          <a:p>
-            <a:pPr eaLnBrk="1" hangingPunct="1"/>
-            <a:endParaRPr lang="en-US" sz="1800" dirty="0"/>
-          </a:p>
-          <a:p>
-            <a:pPr eaLnBrk="1" hangingPunct="1"/>
-            <a:r>
-              <a:rPr lang="en-US" sz="1800" dirty="0"/>
-              <a:t>Add a force </a:t>
-            </a:r>
-          </a:p>
-          <a:p>
-            <a:pPr eaLnBrk="1" hangingPunct="1"/>
-            <a:endParaRPr lang="en-US" sz="1800" dirty="0"/>
-          </a:p>
-          <a:p>
-            <a:pPr eaLnBrk="1" hangingPunct="1">
-              <a:buFontTx/>
-              <a:buNone/>
-            </a:pPr>
-            <a:r>
-              <a:rPr lang="en-US" sz="1800" dirty="0"/>
-              <a:t>     where F</a:t>
-            </a:r>
-            <a:r>
-              <a:rPr lang="en-US" sz="1800" baseline="-25000" dirty="0"/>
-              <a:t>o</a:t>
-            </a:r>
-            <a:r>
-              <a:rPr lang="en-US" sz="1800" dirty="0"/>
-              <a:t> is a constant and where </a:t>
-            </a:r>
-            <a:r>
-              <a:rPr lang="en-US" sz="1800" dirty="0">
-                <a:sym typeface="Symbol" pitchFamily="18" charset="2"/>
-              </a:rPr>
-              <a:t></a:t>
-            </a:r>
-            <a:r>
-              <a:rPr lang="en-US" sz="1800" baseline="-25000" dirty="0"/>
-              <a:t>f</a:t>
-            </a:r>
-            <a:r>
-              <a:rPr lang="en-US" sz="1800" dirty="0"/>
-              <a:t> is the angular frequency of the driving force</a:t>
-            </a:r>
-          </a:p>
-          <a:p>
-            <a:pPr eaLnBrk="1" hangingPunct="1">
-              <a:buFontTx/>
-              <a:buNone/>
-            </a:pPr>
-            <a:endParaRPr lang="en-US" sz="1800" dirty="0"/>
-          </a:p>
-          <a:p>
-            <a:pPr eaLnBrk="1" hangingPunct="1">
-              <a:buFontTx/>
-              <a:buNone/>
-            </a:pPr>
-            <a:endParaRPr lang="en-US" sz="1800" dirty="0"/>
-          </a:p>
-          <a:p>
-            <a:pPr eaLnBrk="1" hangingPunct="1">
-              <a:buFontTx/>
-              <a:buNone/>
-            </a:pPr>
-            <a:endParaRPr lang="en-US" sz="1800" dirty="0"/>
-          </a:p>
-          <a:p>
-            <a:pPr eaLnBrk="1" hangingPunct="1"/>
-            <a:r>
-              <a:rPr lang="en-US" sz="1800" dirty="0"/>
-              <a:t>This one is very hard to solve</a:t>
-            </a:r>
-          </a:p>
-        </p:txBody>
-      </p:sp>
-      <p:sp>
-        <p:nvSpPr>
-          <p:cNvPr id="19461" name="Rectangle 4"/>
-          <p:cNvSpPr>
-            <a:spLocks noChangeArrowheads="1"/>
-          </p:cNvSpPr>
-          <p:nvPr/>
-        </p:nvSpPr>
-        <p:spPr bwMode="auto">
-          <a:xfrm>
-            <a:off x="1143001" y="707209"/>
-            <a:ext cx="184731" cy="300082"/>
-          </a:xfrm>
-          <a:prstGeom prst="rect">
-            <a:avLst/>
-          </a:prstGeom>
-          <a:noFill/>
-          <a:ln>
-            <a:noFill/>
-          </a:ln>
-          <a:extLst>
-            <a:ext uri="{909E8E84-426E-40DD-AFC4-6F175D3DCCD1}">
-              <a14:hiddenFill xmlns:a14="http://schemas.microsoft.com/office/drawing/2010/main">
-                <a:solidFill>
-                  <a:srgbClr val="FFFFFF"/>
-                </a:solidFill>
-              </a14:hiddenFill>
-            </a:ext>
-            <a:ext uri="{91240B29-F687-4F45-9708-019B960494DF}">
-              <a14:hiddenLine xmlns:a14="http://schemas.microsoft.com/office/drawing/2010/main" w="9525" algn="ctr">
-                <a:solidFill>
-                  <a:srgbClr val="000000"/>
-                </a:solidFill>
-                <a:miter lim="800000"/>
-                <a:headEnd/>
-                <a:tailEnd/>
-              </a14:hiddenLine>
-            </a:ext>
-          </a:extLst>
-        </p:spPr>
-        <p:txBody>
-          <a:bodyPr wrap="none" anchor="ctr">
-            <a:spAutoFit/>
-          </a:bodyPr>
-          <a:lstStyle/>
-          <a:p>
-            <a:endParaRPr lang="en-US" sz="1350"/>
-          </a:p>
-        </p:txBody>
-      </p:sp>
-      <p:graphicFrame>
-        <p:nvGraphicFramePr>
-          <p:cNvPr id="19462" name="Object 5"/>
-          <p:cNvGraphicFramePr>
-            <a:graphicFrameLocks noChangeAspect="1"/>
-          </p:cNvGraphicFramePr>
-          <p:nvPr>
-            <p:extLst>
-              <p:ext uri="{D42A27DB-BD31-4B8C-83A1-F6EECF244321}">
-                <p14:modId xmlns:p14="http://schemas.microsoft.com/office/powerpoint/2010/main" val="3118549179"/>
-              </p:ext>
-            </p:extLst>
-          </p:nvPr>
-        </p:nvGraphicFramePr>
-        <p:xfrm>
-          <a:off x="3731481" y="1669537"/>
-          <a:ext cx="757170" cy="292098"/>
-        </p:xfrm>
-        <a:graphic>
-          <a:graphicData uri="http://schemas.openxmlformats.org/presentationml/2006/ole">
-            <mc:AlternateContent xmlns:mc="http://schemas.openxmlformats.org/markup-compatibility/2006">
-              <mc:Choice xmlns:v="urn:schemas-microsoft-com:vml" Requires="v">
-                <p:oleObj name="Equation" r:id="rId2" imgW="596900" imgH="228600" progId="Equation.3">
-                  <p:embed/>
-                </p:oleObj>
-              </mc:Choice>
-              <mc:Fallback>
-                <p:oleObj name="Equation" r:id="rId2" imgW="596900" imgH="228600" progId="Equation.3">
-                  <p:embed/>
-                  <p:pic>
-                    <p:nvPicPr>
-                      <p:cNvPr id="19462" name="Object 5"/>
-                      <p:cNvPicPr>
-                        <a:picLocks noChangeAspect="1" noChangeArrowheads="1"/>
-                      </p:cNvPicPr>
-                      <p:nvPr/>
-                    </p:nvPicPr>
-                    <p:blipFill>
-                      <a:blip r:embed="rId3">
-                        <a:extLst>
-                          <a:ext uri="{28A0092B-C50C-407E-A947-70E740481C1C}">
-                            <a14:useLocalDpi xmlns:a14="http://schemas.microsoft.com/office/drawing/2010/main" val="0"/>
-                          </a:ext>
-                        </a:extLst>
-                      </a:blip>
-                      <a:srcRect/>
-                      <a:stretch>
-                        <a:fillRect/>
-                      </a:stretch>
-                    </p:blipFill>
-                    <p:spPr bwMode="auto">
-                      <a:xfrm>
-                        <a:off x="3731481" y="1669537"/>
-                        <a:ext cx="757170" cy="292098"/>
-                      </a:xfrm>
-                      <a:prstGeom prst="rect">
-                        <a:avLst/>
-                      </a:prstGeom>
-                      <a:noFill/>
-                      <a:ln>
-                        <a:noFill/>
-                      </a:ln>
-                    </p:spPr>
-                  </p:pic>
-                </p:oleObj>
-              </mc:Fallback>
-            </mc:AlternateContent>
-          </a:graphicData>
-        </a:graphic>
-      </p:graphicFrame>
-      <p:sp>
-        <p:nvSpPr>
-          <p:cNvPr id="19463" name="Rectangle 6"/>
-          <p:cNvSpPr>
-            <a:spLocks noChangeArrowheads="1"/>
-          </p:cNvSpPr>
-          <p:nvPr/>
-        </p:nvSpPr>
-        <p:spPr bwMode="auto">
-          <a:xfrm>
-            <a:off x="1143001" y="707209"/>
-            <a:ext cx="184731" cy="300082"/>
-          </a:xfrm>
-          <a:prstGeom prst="rect">
-            <a:avLst/>
-          </a:prstGeom>
-          <a:noFill/>
-          <a:ln>
-            <a:noFill/>
-          </a:ln>
-          <a:extLst>
-            <a:ext uri="{909E8E84-426E-40DD-AFC4-6F175D3DCCD1}">
-              <a14:hiddenFill xmlns:a14="http://schemas.microsoft.com/office/drawing/2010/main">
-                <a:solidFill>
-                  <a:srgbClr val="FFFFFF"/>
-                </a:solidFill>
-              </a14:hiddenFill>
-            </a:ext>
-            <a:ext uri="{91240B29-F687-4F45-9708-019B960494DF}">
-              <a14:hiddenLine xmlns:a14="http://schemas.microsoft.com/office/drawing/2010/main" w="9525" algn="ctr">
-                <a:solidFill>
-                  <a:srgbClr val="000000"/>
-                </a:solidFill>
-                <a:miter lim="800000"/>
-                <a:headEnd/>
-                <a:tailEnd/>
-              </a14:hiddenLine>
-            </a:ext>
-          </a:extLst>
-        </p:spPr>
-        <p:txBody>
-          <a:bodyPr wrap="none" anchor="ctr">
-            <a:spAutoFit/>
-          </a:bodyPr>
-          <a:lstStyle/>
-          <a:p>
-            <a:endParaRPr lang="en-US" sz="1350"/>
-          </a:p>
-        </p:txBody>
-      </p:sp>
-      <p:graphicFrame>
-        <p:nvGraphicFramePr>
-          <p:cNvPr id="19464" name="Object 7"/>
-          <p:cNvGraphicFramePr>
-            <a:graphicFrameLocks noChangeAspect="1"/>
-          </p:cNvGraphicFramePr>
-          <p:nvPr>
-            <p:extLst>
-              <p:ext uri="{D42A27DB-BD31-4B8C-83A1-F6EECF244321}">
-                <p14:modId xmlns:p14="http://schemas.microsoft.com/office/powerpoint/2010/main" val="1315654589"/>
-              </p:ext>
-            </p:extLst>
-          </p:nvPr>
-        </p:nvGraphicFramePr>
-        <p:xfrm>
-          <a:off x="2109932" y="2860706"/>
-          <a:ext cx="1990990" cy="436308"/>
-        </p:xfrm>
-        <a:graphic>
-          <a:graphicData uri="http://schemas.openxmlformats.org/presentationml/2006/ole">
-            <mc:AlternateContent xmlns:mc="http://schemas.openxmlformats.org/markup-compatibility/2006">
-              <mc:Choice xmlns:v="urn:schemas-microsoft-com:vml" Requires="v">
-                <p:oleObj name="Equation" r:id="rId4" imgW="1104900" imgH="241300" progId="Equation.3">
-                  <p:embed/>
-                </p:oleObj>
-              </mc:Choice>
-              <mc:Fallback>
-                <p:oleObj name="Equation" r:id="rId4" imgW="1104900" imgH="241300" progId="Equation.3">
-                  <p:embed/>
-                  <p:pic>
-                    <p:nvPicPr>
-                      <p:cNvPr id="19464" name="Object 7"/>
-                      <p:cNvPicPr>
-                        <a:picLocks noChangeAspect="1" noChangeArrowheads="1"/>
-                      </p:cNvPicPr>
-                      <p:nvPr/>
-                    </p:nvPicPr>
-                    <p:blipFill>
-                      <a:blip r:embed="rId5">
-                        <a:extLst>
-                          <a:ext uri="{28A0092B-C50C-407E-A947-70E740481C1C}">
-                            <a14:useLocalDpi xmlns:a14="http://schemas.microsoft.com/office/drawing/2010/main" val="0"/>
-                          </a:ext>
-                        </a:extLst>
-                      </a:blip>
-                      <a:srcRect/>
-                      <a:stretch>
-                        <a:fillRect/>
-                      </a:stretch>
-                    </p:blipFill>
-                    <p:spPr bwMode="auto">
-                      <a:xfrm>
-                        <a:off x="2109932" y="2860706"/>
-                        <a:ext cx="1990990" cy="436308"/>
-                      </a:xfrm>
-                      <a:prstGeom prst="rect">
-                        <a:avLst/>
-                      </a:prstGeom>
-                      <a:noFill/>
-                      <a:ln>
-                        <a:noFill/>
-                      </a:ln>
-                    </p:spPr>
-                  </p:pic>
-                </p:oleObj>
-              </mc:Fallback>
-            </mc:AlternateContent>
-          </a:graphicData>
-        </a:graphic>
-      </p:graphicFrame>
-      <p:graphicFrame>
-        <p:nvGraphicFramePr>
-          <p:cNvPr id="19465" name="Object 8"/>
-          <p:cNvGraphicFramePr>
-            <a:graphicFrameLocks noChangeAspect="1"/>
-          </p:cNvGraphicFramePr>
-          <p:nvPr>
-            <p:extLst>
-              <p:ext uri="{D42A27DB-BD31-4B8C-83A1-F6EECF244321}">
-                <p14:modId xmlns:p14="http://schemas.microsoft.com/office/powerpoint/2010/main" val="1468611588"/>
-              </p:ext>
-            </p:extLst>
-          </p:nvPr>
-        </p:nvGraphicFramePr>
-        <p:xfrm>
-          <a:off x="2482883" y="4275280"/>
-          <a:ext cx="3585914" cy="436309"/>
-        </p:xfrm>
-        <a:graphic>
-          <a:graphicData uri="http://schemas.openxmlformats.org/presentationml/2006/ole">
-            <mc:AlternateContent xmlns:mc="http://schemas.openxmlformats.org/markup-compatibility/2006">
-              <mc:Choice xmlns:v="urn:schemas-microsoft-com:vml" Requires="v">
-                <p:oleObj name="Equation" r:id="rId6" imgW="1993900" imgH="241300" progId="Equation.3">
-                  <p:embed/>
-                </p:oleObj>
-              </mc:Choice>
-              <mc:Fallback>
-                <p:oleObj name="Equation" r:id="rId6" imgW="1993900" imgH="241300" progId="Equation.3">
-                  <p:embed/>
-                  <p:pic>
-                    <p:nvPicPr>
-                      <p:cNvPr id="19465" name="Object 8"/>
-                      <p:cNvPicPr>
-                        <a:picLocks noChangeAspect="1" noChangeArrowheads="1"/>
-                      </p:cNvPicPr>
-                      <p:nvPr/>
-                    </p:nvPicPr>
-                    <p:blipFill>
-                      <a:blip r:embed="rId7">
-                        <a:extLst>
-                          <a:ext uri="{28A0092B-C50C-407E-A947-70E740481C1C}">
-                            <a14:useLocalDpi xmlns:a14="http://schemas.microsoft.com/office/drawing/2010/main" val="0"/>
-                          </a:ext>
-                        </a:extLst>
-                      </a:blip>
-                      <a:srcRect/>
-                      <a:stretch>
-                        <a:fillRect/>
-                      </a:stretch>
-                    </p:blipFill>
-                    <p:spPr bwMode="auto">
-                      <a:xfrm>
-                        <a:off x="2482883" y="4275280"/>
-                        <a:ext cx="3585914" cy="436309"/>
-                      </a:xfrm>
-                      <a:prstGeom prst="rect">
-                        <a:avLst/>
-                      </a:prstGeom>
-                      <a:noFill/>
-                      <a:ln>
-                        <a:noFill/>
-                      </a:ln>
-                    </p:spPr>
-                  </p:pic>
-                </p:oleObj>
-              </mc:Fallback>
-            </mc:AlternateContent>
-          </a:graphicData>
-        </a:graphic>
-      </p:graphicFrame>
-    </p:spTree>
-  </p:cSld>
-  <p:clrMapOvr>
-    <a:masterClrMapping/>
-  </p:clrMapOvr>
-</p:sld>
-</file>
-
-<file path=ppt/slides/slide40.xml><?xml version="1.0" encoding="utf-8"?>
+<file path=ppt/slides/slide41.xml><?xml version="1.0" encoding="utf-8"?>
 <p:sld xmlns:a="http://schemas.openxmlformats.org/drawingml/2006/main" xmlns:r="http://schemas.openxmlformats.org/officeDocument/2006/relationships" xmlns:p="http://schemas.openxmlformats.org/presentationml/2006/main">
   <p:cSld>
     <p:spTree>
@@ -30233,7 +30126,7 @@
 </p:sld>
 </file>
 
-<file path=ppt/slides/slide41.xml><?xml version="1.0" encoding="utf-8"?>
+<file path=ppt/slides/slide42.xml><?xml version="1.0" encoding="utf-8"?>
 <p:sld xmlns:a="http://schemas.openxmlformats.org/drawingml/2006/main" xmlns:r="http://schemas.openxmlformats.org/officeDocument/2006/relationships" xmlns:p="http://schemas.openxmlformats.org/presentationml/2006/main">
   <p:cSld>
     <p:spTree>
@@ -34455,7 +34348,7 @@
 </p:sld>
 </file>
 
-<file path=ppt/slides/slide42.xml><?xml version="1.0" encoding="utf-8"?>
+<file path=ppt/slides/slide43.xml><?xml version="1.0" encoding="utf-8"?>
 <p:sld xmlns:a="http://schemas.openxmlformats.org/drawingml/2006/main" xmlns:r="http://schemas.openxmlformats.org/officeDocument/2006/relationships" xmlns:p="http://schemas.openxmlformats.org/presentationml/2006/main">
   <p:cSld>
     <p:spTree>
@@ -39336,7 +39229,7 @@
 </p:sld>
 </file>
 
-<file path=ppt/slides/slide43.xml><?xml version="1.0" encoding="utf-8"?>
+<file path=ppt/slides/slide44.xml><?xml version="1.0" encoding="utf-8"?>
 <p:sld xmlns:a="http://schemas.openxmlformats.org/drawingml/2006/main" xmlns:r="http://schemas.openxmlformats.org/officeDocument/2006/relationships" xmlns:p="http://schemas.openxmlformats.org/presentationml/2006/main">
   <p:cSld>
     <p:spTree>
@@ -44187,7 +44080,7 @@
 </p:sld>
 </file>
 
-<file path=ppt/slides/slide44.xml><?xml version="1.0" encoding="utf-8"?>
+<file path=ppt/slides/slide45.xml><?xml version="1.0" encoding="utf-8"?>
 <p:sld xmlns:a="http://schemas.openxmlformats.org/drawingml/2006/main" xmlns:r="http://schemas.openxmlformats.org/officeDocument/2006/relationships" xmlns:p="http://schemas.openxmlformats.org/presentationml/2006/main">
   <p:cSld>
     <p:spTree>
@@ -48984,7 +48877,7 @@
 </p:sld>
 </file>
 
-<file path=ppt/slides/slide45.xml><?xml version="1.0" encoding="utf-8"?>
+<file path=ppt/slides/slide46.xml><?xml version="1.0" encoding="utf-8"?>
 <p:sld xmlns:a="http://schemas.openxmlformats.org/drawingml/2006/main" xmlns:r="http://schemas.openxmlformats.org/officeDocument/2006/relationships" xmlns:p="http://schemas.openxmlformats.org/presentationml/2006/main">
   <p:cSld>
     <p:spTree>
@@ -49121,7 +49014,7 @@
               <a:pPr>
                 <a:defRPr/>
               </a:pPr>
-              <a:t>45</a:t>
+              <a:t>46</a:t>
             </a:fld>
             <a:endParaRPr lang="en-US"/>
           </a:p>
@@ -49994,7 +49887,7 @@
 </p:sld>
 </file>
 
-<file path=ppt/slides/slide46.xml><?xml version="1.0" encoding="utf-8"?>
+<file path=ppt/slides/slide47.xml><?xml version="1.0" encoding="utf-8"?>
 <p:sld xmlns:a="http://schemas.openxmlformats.org/drawingml/2006/main" xmlns:r="http://schemas.openxmlformats.org/officeDocument/2006/relationships" xmlns:p="http://schemas.openxmlformats.org/presentationml/2006/main">
   <p:cSld>
     <p:spTree>
@@ -50202,7 +50095,7 @@
               <a:pPr>
                 <a:defRPr/>
               </a:pPr>
-              <a:t>46</a:t>
+              <a:t>47</a:t>
             </a:fld>
             <a:endParaRPr lang="en-US"/>
           </a:p>
@@ -50763,7 +50656,7 @@
 </p:sld>
 </file>
 
-<file path=ppt/slides/slide47.xml><?xml version="1.0" encoding="utf-8"?>
+<file path=ppt/slides/slide48.xml><?xml version="1.0" encoding="utf-8"?>
 <p:sld xmlns:a="http://schemas.openxmlformats.org/drawingml/2006/main" xmlns:r="http://schemas.openxmlformats.org/officeDocument/2006/relationships" xmlns:p="http://schemas.openxmlformats.org/presentationml/2006/main">
   <p:cSld>
     <p:spTree>
@@ -50886,7 +50779,7 @@
               <a:pPr>
                 <a:defRPr/>
               </a:pPr>
-              <a:t>47</a:t>
+              <a:t>48</a:t>
             </a:fld>
             <a:endParaRPr lang="en-US"/>
           </a:p>
@@ -51337,8 +51230,8 @@
           </a:p>
         </p:txBody>
       </p:sp>
-      <mc:AlternateContent xmlns:mc="http://schemas.openxmlformats.org/markup-compatibility/2006">
-        <mc:Choice xmlns:a14="http://schemas.microsoft.com/office/drawing/2010/main" Requires="a14">
+      <mc:AlternateContent xmlns:mc="http://schemas.openxmlformats.org/markup-compatibility/2006" xmlns:a14="http://schemas.microsoft.com/office/drawing/2010/main">
+        <mc:Choice Requires="a14">
           <p:sp>
             <p:nvSpPr>
               <p:cNvPr id="20488" name="Object 7"/>
@@ -51370,7 +51263,7 @@
                     <m:oMathParaPr>
                       <m:jc m:val="left"/>
                     </m:oMathParaPr>
-                    <m:oMath xmlns:m="http://schemas.openxmlformats.org/officeDocument/2006/math">
+                    <m:oMath>
                       <m:r>
                         <a:rPr lang="en-US" i="1" smtClean="0">
                           <a:solidFill>
@@ -51742,7 +51635,7 @@
             </p:txBody>
           </p:sp>
         </mc:Choice>
-        <mc:Fallback>
+        <mc:Fallback xmlns="">
           <p:sp>
             <p:nvSpPr>
               <p:cNvPr id="20488" name="Object 7"/>
@@ -51834,8 +51727,8 @@
           </a:p>
         </p:txBody>
       </p:sp>
-      <mc:AlternateContent xmlns:mc="http://schemas.openxmlformats.org/markup-compatibility/2006">
-        <mc:Choice xmlns:a14="http://schemas.microsoft.com/office/drawing/2010/main" Requires="a14">
+      <mc:AlternateContent xmlns:mc="http://schemas.openxmlformats.org/markup-compatibility/2006" xmlns:a14="http://schemas.microsoft.com/office/drawing/2010/main">
+        <mc:Choice Requires="a14">
           <p:sp>
             <p:nvSpPr>
               <p:cNvPr id="20490" name="Object 9"/>
@@ -51867,11 +51760,11 @@
                     <m:oMathParaPr>
                       <m:jc m:val="left"/>
                     </m:oMathParaPr>
-                    <m:oMath xmlns:m="http://schemas.openxmlformats.org/officeDocument/2006/math">
+                    <m:oMath>
                       <m:sSub>
                         <m:sSubPr>
                           <m:ctrlPr>
-                            <a:rPr lang="en-US" i="1" smtClean="0">
+                            <a:rPr lang="en-US" i="1">
                               <a:solidFill>
                                 <a:srgbClr val="000000"/>
                               </a:solidFill>
@@ -51969,7 +51862,7 @@
             </p:txBody>
           </p:sp>
         </mc:Choice>
-        <mc:Fallback>
+        <mc:Fallback xmlns="">
           <p:sp>
             <p:nvSpPr>
               <p:cNvPr id="20490" name="Object 9"/>
@@ -52011,8 +51904,8 @@
           </p:sp>
         </mc:Fallback>
       </mc:AlternateContent>
-      <mc:AlternateContent xmlns:mc="http://schemas.openxmlformats.org/markup-compatibility/2006">
-        <mc:Choice xmlns:a14="http://schemas.microsoft.com/office/drawing/2010/main" Requires="a14">
+      <mc:AlternateContent xmlns:mc="http://schemas.openxmlformats.org/markup-compatibility/2006" xmlns:a14="http://schemas.microsoft.com/office/drawing/2010/main">
+        <mc:Choice Requires="a14">
           <p:sp>
             <p:nvSpPr>
               <p:cNvPr id="20491" name="Object 10"/>
@@ -52044,7 +51937,7 @@
                     <m:oMathParaPr>
                       <m:jc m:val="left"/>
                     </m:oMathParaPr>
-                    <m:oMath xmlns:m="http://schemas.openxmlformats.org/officeDocument/2006/math">
+                    <m:oMath>
                       <m:r>
                         <a:rPr lang="en-US" i="1" smtClean="0">
                           <a:solidFill>
@@ -52380,7 +52273,7 @@
             </p:txBody>
           </p:sp>
         </mc:Choice>
-        <mc:Fallback>
+        <mc:Fallback xmlns="">
           <p:sp>
             <p:nvSpPr>
               <p:cNvPr id="20491" name="Object 10"/>
@@ -52422,8 +52315,8 @@
           </p:sp>
         </mc:Fallback>
       </mc:AlternateContent>
-      <mc:AlternateContent xmlns:mc="http://schemas.openxmlformats.org/markup-compatibility/2006">
-        <mc:Choice xmlns:a14="http://schemas.microsoft.com/office/drawing/2010/main" Requires="a14">
+      <mc:AlternateContent xmlns:mc="http://schemas.openxmlformats.org/markup-compatibility/2006" xmlns:a14="http://schemas.microsoft.com/office/drawing/2010/main">
+        <mc:Choice Requires="a14">
           <p:sp>
             <p:nvSpPr>
               <p:cNvPr id="20492" name="Object 11"/>
@@ -52455,7 +52348,7 @@
                     <m:oMathParaPr>
                       <m:jc m:val="left"/>
                     </m:oMathParaPr>
-                    <m:oMath xmlns:m="http://schemas.openxmlformats.org/officeDocument/2006/math">
+                    <m:oMath>
                       <m:r>
                         <a:rPr lang="en-US" i="1">
                           <a:solidFill>
@@ -52509,7 +52402,7 @@
                       <m:func>
                         <m:funcPr>
                           <m:ctrlPr>
-                            <a:rPr lang="en-US" i="1">
+                            <a:rPr lang="en-US" i="0">
                               <a:solidFill>
                                 <a:srgbClr val="000000"/>
                               </a:solidFill>
@@ -52592,7 +52485,7 @@
             </p:txBody>
           </p:sp>
         </mc:Choice>
-        <mc:Fallback>
+        <mc:Fallback xmlns="">
           <p:sp>
             <p:nvSpPr>
               <p:cNvPr id="20492" name="Object 11"/>
@@ -52920,8 +52813,8 @@
           </a:p>
         </p:txBody>
       </p:sp>
-      <mc:AlternateContent xmlns:mc="http://schemas.openxmlformats.org/markup-compatibility/2006">
-        <mc:Choice xmlns:a14="http://schemas.microsoft.com/office/drawing/2010/main" Requires="a14">
+      <mc:AlternateContent xmlns:mc="http://schemas.openxmlformats.org/markup-compatibility/2006" xmlns:a14="http://schemas.microsoft.com/office/drawing/2010/main">
+        <mc:Choice Requires="a14">
           <p:sp>
             <p:nvSpPr>
               <p:cNvPr id="21510" name="Object 5"/>
@@ -52953,7 +52846,7 @@
                     <m:oMathParaPr>
                       <m:jc m:val="left"/>
                     </m:oMathParaPr>
-                    <m:oMath xmlns:m="http://schemas.openxmlformats.org/officeDocument/2006/math">
+                    <m:oMath>
                       <m:r>
                         <a:rPr lang="en-US" i="1" smtClean="0">
                           <a:solidFill>
@@ -53289,7 +53182,7 @@
             </p:txBody>
           </p:sp>
         </mc:Choice>
-        <mc:Fallback>
+        <mc:Fallback xmlns="">
           <p:sp>
             <p:nvSpPr>
               <p:cNvPr id="21510" name="Object 5"/>
@@ -54055,8 +53948,8 @@
           </a:p>
         </p:txBody>
       </p:sp>
-      <mc:AlternateContent xmlns:mc="http://schemas.openxmlformats.org/markup-compatibility/2006">
-        <mc:Choice xmlns:a14="http://schemas.microsoft.com/office/drawing/2010/main" Requires="a14">
+      <mc:AlternateContent xmlns:mc="http://schemas.openxmlformats.org/markup-compatibility/2006" xmlns:a14="http://schemas.microsoft.com/office/drawing/2010/main">
+        <mc:Choice Requires="a14">
           <p:sp>
             <p:nvSpPr>
               <p:cNvPr id="22536" name="Object 7"/>
@@ -54088,7 +53981,7 @@
                     <m:oMathParaPr>
                       <m:jc m:val="left"/>
                     </m:oMathParaPr>
-                    <m:oMath xmlns:m="http://schemas.openxmlformats.org/officeDocument/2006/math">
+                    <m:oMath>
                       <m:r>
                         <a:rPr lang="en-US" i="1" smtClean="0">
                           <a:solidFill>
@@ -54167,7 +54060,7 @@
                       <m:func>
                         <m:funcPr>
                           <m:ctrlPr>
-                            <a:rPr lang="en-US" i="1">
+                            <a:rPr lang="en-US" i="0">
                               <a:solidFill>
                                 <a:srgbClr val="000000"/>
                               </a:solidFill>
@@ -54232,7 +54125,7 @@
             </p:txBody>
           </p:sp>
         </mc:Choice>
-        <mc:Fallback>
+        <mc:Fallback xmlns="">
           <p:sp>
             <p:nvSpPr>
               <p:cNvPr id="22536" name="Object 7"/>
@@ -55339,8 +55232,8 @@
         </p:nvSpPr>
         <p:spPr>
           <a:xfrm>
-            <a:off x="1404194" y="1731764"/>
-            <a:ext cx="6335611" cy="3394472"/>
+            <a:off x="541867" y="1731764"/>
+            <a:ext cx="7890933" cy="3394472"/>
           </a:xfrm>
         </p:spPr>
         <p:txBody>
@@ -55372,6 +55265,36 @@
           </a:p>
         </p:txBody>
       </p:sp>
+      <p:pic>
+        <p:nvPicPr>
+          <p:cNvPr id="2" name="Picture 1" descr="File:Tacoma Narrows Bridge Falling.png">
+            <a:extLst>
+              <a:ext uri="{FF2B5EF4-FFF2-40B4-BE49-F238E27FC236}">
+                <a16:creationId xmlns:a16="http://schemas.microsoft.com/office/drawing/2014/main" id="{97DA0287-7C11-6853-614F-8CB4B73A9652}"/>
+              </a:ext>
+            </a:extLst>
+          </p:cNvPr>
+          <p:cNvPicPr>
+            <a:picLocks noChangeAspect="1"/>
+          </p:cNvPicPr>
+          <p:nvPr/>
+        </p:nvPicPr>
+        <p:blipFill>
+          <a:blip r:embed="rId2"/>
+          <a:stretch>
+            <a:fillRect/>
+          </a:stretch>
+        </p:blipFill>
+        <p:spPr>
+          <a:xfrm>
+            <a:off x="2984698" y="4321475"/>
+            <a:ext cx="3174603" cy="2400000"/>
+          </a:xfrm>
+          <a:prstGeom prst="rect">
+            <a:avLst/>
+          </a:prstGeom>
+        </p:spPr>
+      </p:pic>
     </p:spTree>
   </p:cSld>
   <p:clrMapOvr>

</xml_diff>